<commit_message>
M14: Sim-Review umgesetzt (sim_review true, Inhalt aktualisiert)
Co-Authored-By: Claude Opus 4.8 <noreply@anthropic.com>
</commit_message>
<xml_diff>
--- a/protected-downloads/praesentation/M14.pptx
+++ b/protected-downloads/praesentation/M14.pptx
@@ -8997,7 +8997,7 @@
                 </a:solidFill>
                 <a:latin typeface="Consolas"/>
               </a:rPr>
-              <a:t>5–25 min    </a:t>
+              <a:t>5–30 min    </a:t>
             </a:r>
             <a:r>
               <a:rPr sz="1500" b="1">
@@ -9034,7 +9034,7 @@
                 </a:solidFill>
                 <a:latin typeface="Consolas"/>
               </a:rPr>
-              <a:t>25–45 min   </a:t>
+              <a:t>30–50 min   </a:t>
             </a:r>
             <a:r>
               <a:rPr sz="1500" b="1">
@@ -9071,7 +9071,7 @@
                 </a:solidFill>
                 <a:latin typeface="Consolas"/>
               </a:rPr>
-              <a:t>45–55 min   </a:t>
+              <a:t>50–62 min   </a:t>
             </a:r>
             <a:r>
               <a:rPr sz="1500" b="1">
@@ -9108,7 +9108,7 @@
                 </a:solidFill>
                 <a:latin typeface="Consolas"/>
               </a:rPr>
-              <a:t>55–70 min   </a:t>
+              <a:t>62–76 min   </a:t>
             </a:r>
             <a:r>
               <a:rPr sz="1500" b="1">
@@ -9145,7 +9145,7 @@
                 </a:solidFill>
                 <a:latin typeface="Consolas"/>
               </a:rPr>
-              <a:t>70–82 min   </a:t>
+              <a:t>76–92 min   </a:t>
             </a:r>
             <a:r>
               <a:rPr sz="1500" b="1">
@@ -9163,7 +9163,7 @@
                 </a:solidFill>
                 <a:latin typeface="Arial"/>
               </a:rPr>
-              <a:t>  ·  Paare</a:t>
+              <a:t>  ·  Dreiergruppen, 2 Runden mit Rollentausch</a:t>
             </a:r>
           </a:p>
           <a:p>
@@ -9182,7 +9182,7 @@
                 </a:solidFill>
                 <a:latin typeface="Consolas"/>
               </a:rPr>
-              <a:t>82–88 min   </a:t>
+              <a:t>92–97 min   </a:t>
             </a:r>
             <a:r>
               <a:rPr sz="1500" b="1">
@@ -9219,7 +9219,7 @@
                 </a:solidFill>
                 <a:latin typeface="Consolas"/>
               </a:rPr>
-              <a:t>88–90 min   </a:t>
+              <a:t>97–100 min  </a:t>
             </a:r>
             <a:r>
               <a:rPr sz="1500" b="1">

</xml_diff>

<commit_message>
M-Track Batch 3: M14 Deck (Web/Workbook)
Co-Authored-By: Claude Fable 5 <noreply@anthropic.com>
</commit_message>
<xml_diff>
--- a/protected-downloads/praesentation/M14.pptx
+++ b/protected-downloads/praesentation/M14.pptx
@@ -20,7 +20,6 @@
     <p:sldId id="268" r:id="rId20"/>
     <p:sldId id="269" r:id="rId21"/>
     <p:sldId id="270" r:id="rId22"/>
-    <p:sldId id="271" r:id="rId23"/>
   </p:sldIdLst>
   <p:sldSz cx="12188952" cy="6858000" type="screen4x3"/>
   <p:notesSz cx="6858000" cy="9144000"/>
@@ -542,146 +541,6 @@
 </p:notes>
 </file>
 
-<file path=ppt/notesSlides/notesSlide10.xml><?xml version="1.0" encoding="utf-8"?>
-<p:notes xmlns:a="http://schemas.openxmlformats.org/drawingml/2006/main" xmlns:p="http://schemas.openxmlformats.org/presentationml/2006/main" xmlns:r="http://schemas.openxmlformats.org/officeDocument/2006/relationships">
-  <p:cSld>
-    <p:spTree>
-      <p:nvGrpSpPr>
-        <p:cNvPr id="1" name=""/>
-        <p:cNvGrpSpPr/>
-        <p:nvPr/>
-      </p:nvGrpSpPr>
-      <p:grpSpPr>
-        <a:xfrm>
-          <a:off x="0" y="0"/>
-          <a:ext cx="0" cy="0"/>
-          <a:chOff x="0" y="0"/>
-          <a:chExt cx="0" cy="0"/>
-        </a:xfrm>
-      </p:grpSpPr>
-      <p:sp>
-        <p:nvSpPr>
-          <p:cNvPr id="2" name="Slide Image Placeholder 1"/>
-          <p:cNvSpPr>
-            <a:spLocks noGrp="1"/>
-          </p:cNvSpPr>
-          <p:nvPr>
-            <p:ph type="sldImg" idx="2"/>
-          </p:nvPr>
-        </p:nvSpPr>
-        <p:spPr/>
-      </p:sp>
-      <p:sp>
-        <p:nvSpPr>
-          <p:cNvPr id="3" name="Notes Placeholder 2"/>
-          <p:cNvSpPr>
-            <a:spLocks noGrp="1"/>
-          </p:cNvSpPr>
-          <p:nvPr>
-            <p:ph type="body" idx="3" sz="quarter"/>
-          </p:nvPr>
-        </p:nvSpPr>
-        <p:spPr/>
-        <p:txBody>
-          <a:bodyPr/>
-          <a:lstStyle/>
-          <a:p>
-            <a:r>
-              <a:t>Siehe Trainerhandbuch (Sektion 3) für Moderationshinweise, Timing und erwartete Teilnehmerreaktionen.</a:t>
-            </a:r>
-          </a:p>
-        </p:txBody>
-      </p:sp>
-      <p:sp>
-        <p:nvSpPr>
-          <p:cNvPr id="4" name="Slide Number Placeholder 3"/>
-          <p:cNvSpPr>
-            <a:spLocks noGrp="1"/>
-          </p:cNvSpPr>
-          <p:nvPr>
-            <p:ph type="sldNum" idx="5" sz="quarter"/>
-          </p:nvPr>
-        </p:nvSpPr>
-        <p:spPr/>
-      </p:sp>
-    </p:spTree>
-  </p:cSld>
-  <p:clrMapOvr>
-    <a:masterClrMapping/>
-  </p:clrMapOvr>
-</p:notes>
-</file>
-
-<file path=ppt/notesSlides/notesSlide11.xml><?xml version="1.0" encoding="utf-8"?>
-<p:notes xmlns:a="http://schemas.openxmlformats.org/drawingml/2006/main" xmlns:p="http://schemas.openxmlformats.org/presentationml/2006/main" xmlns:r="http://schemas.openxmlformats.org/officeDocument/2006/relationships">
-  <p:cSld>
-    <p:spTree>
-      <p:nvGrpSpPr>
-        <p:cNvPr id="1" name=""/>
-        <p:cNvGrpSpPr/>
-        <p:nvPr/>
-      </p:nvGrpSpPr>
-      <p:grpSpPr>
-        <a:xfrm>
-          <a:off x="0" y="0"/>
-          <a:ext cx="0" cy="0"/>
-          <a:chOff x="0" y="0"/>
-          <a:chExt cx="0" cy="0"/>
-        </a:xfrm>
-      </p:grpSpPr>
-      <p:sp>
-        <p:nvSpPr>
-          <p:cNvPr id="2" name="Slide Image Placeholder 1"/>
-          <p:cNvSpPr>
-            <a:spLocks noGrp="1"/>
-          </p:cNvSpPr>
-          <p:nvPr>
-            <p:ph type="sldImg" idx="2"/>
-          </p:nvPr>
-        </p:nvSpPr>
-        <p:spPr/>
-      </p:sp>
-      <p:sp>
-        <p:nvSpPr>
-          <p:cNvPr id="3" name="Notes Placeholder 2"/>
-          <p:cNvSpPr>
-            <a:spLocks noGrp="1"/>
-          </p:cNvSpPr>
-          <p:nvPr>
-            <p:ph type="body" idx="3" sz="quarter"/>
-          </p:nvPr>
-        </p:nvSpPr>
-        <p:spPr/>
-        <p:txBody>
-          <a:bodyPr/>
-          <a:lstStyle/>
-          <a:p>
-            <a:r>
-              <a:t>Siehe Trainerhandbuch (Sektion 3) für Moderationshinweise, Timing und erwartete Teilnehmerreaktionen.</a:t>
-            </a:r>
-          </a:p>
-        </p:txBody>
-      </p:sp>
-      <p:sp>
-        <p:nvSpPr>
-          <p:cNvPr id="4" name="Slide Number Placeholder 3"/>
-          <p:cNvSpPr>
-            <a:spLocks noGrp="1"/>
-          </p:cNvSpPr>
-          <p:nvPr>
-            <p:ph type="sldNum" idx="5" sz="quarter"/>
-          </p:nvPr>
-        </p:nvSpPr>
-        <p:spPr/>
-      </p:sp>
-    </p:spTree>
-  </p:cSld>
-  <p:clrMapOvr>
-    <a:masterClrMapping/>
-  </p:clrMapOvr>
-</p:notes>
-</file>
-
 <file path=ppt/notesSlides/notesSlide2.xml><?xml version="1.0" encoding="utf-8"?>
 <p:notes xmlns:a="http://schemas.openxmlformats.org/drawingml/2006/main" xmlns:p="http://schemas.openxmlformats.org/presentationml/2006/main" xmlns:r="http://schemas.openxmlformats.org/officeDocument/2006/relationships">
   <p:cSld>
@@ -727,7 +586,7 @@
           <a:lstStyle/>
           <a:p>
             <a:r>
-              <a:t>Siehe Trainerhandbuch (Sektion 3) für Moderationshinweise, Timing und erwartete Teilnehmerreaktionen.</a:t>
+              <a:t>Einstieg: „Welcher Ihrer größten Kunden bringt womöglich am wenigsten Ertrag?"</a:t>
             </a:r>
           </a:p>
         </p:txBody>
@@ -797,7 +656,7 @@
           <a:lstStyle/>
           <a:p>
             <a:r>
-              <a:t>Siehe Trainerhandbuch (Sektion 3) für Moderationshinweise, Timing und erwartete Teilnehmerreaktionen.</a:t>
+              <a:t>Der Deckungsbeitrags-Wasserfall macht sichtbar, wo der Ertrag entsteht und wo er verloren geht.</a:t>
             </a:r>
           </a:p>
         </p:txBody>
@@ -867,7 +726,7 @@
           <a:lstStyle/>
           <a:p>
             <a:r>
-              <a:t>Siehe Trainerhandbuch (Sektion 3) für Moderationshinweise, Timing und erwartete Teilnehmerreaktionen.</a:t>
+              <a:t>Ein risikoreicher Kunde braucht eine höhere Marge – sonst subventioniert die Bank das Risiko.</a:t>
             </a:r>
           </a:p>
         </p:txBody>
@@ -937,7 +796,7 @@
           <a:lstStyle/>
           <a:p>
             <a:r>
-              <a:t>Siehe Trainerhandbuch (Sektion 3) für Moderationshinweise, Timing und erwartete Teilnehmerreaktionen.</a:t>
+              <a:t>Müller GmbH: DB II 12.610 EUR, Rendite 1,58 %. Das XLSX-Deckungsbeitragsmodell (M14) rechnet DB und Expected Loss mit Optimierungsszenarien.</a:t>
             </a:r>
           </a:p>
         </p:txBody>
@@ -1007,7 +866,7 @@
           <a:lstStyle/>
           <a:p>
             <a:r>
-              <a:t>Siehe Trainerhandbuch (Sektion 3) für Moderationshinweise, Timing und erwartete Teilnehmerreaktionen.</a:t>
+              <a:t>Die Handlungsempfehlung verbindet Ertragssignal und Gesprächsstrategie.</a:t>
             </a:r>
           </a:p>
         </p:txBody>
@@ -1077,7 +936,12 @@
           <a:lstStyle/>
           <a:p>
             <a:r>
-              <a:t>Siehe Trainerhandbuch (Sektion 3) für Moderationshinweise, Timing und erwartete Teilnehmerreaktionen.</a:t>
+              <a:t>AB Musterlösung (Trainer-Version)</a:t>
+            </a:r>
+          </a:p>
+          <a:p>
+            <a:r>
+              <a:t>Ziel: die Rendite über Cross-Selling und risikogerechte Kondition zum NMZ bringen – im Gespräch über Wert, nicht über Nachlass.</a:t>
             </a:r>
           </a:p>
         </p:txBody>
@@ -1147,7 +1011,7 @@
           <a:lstStyle/>
           <a:p>
             <a:r>
-              <a:t>Siehe Trainerhandbuch (Sektion 3) für Moderationshinweise, Timing und erwartete Teilnehmerreaktionen.</a:t>
+              <a:t>Überleitung zum Selbstcheck.</a:t>
             </a:r>
           </a:p>
         </p:txBody>
@@ -1217,7 +1081,7 @@
           <a:lstStyle/>
           <a:p>
             <a:r>
-              <a:t>Siehe Trainerhandbuch (Sektion 3) für Moderationshinweise, Timing und erwartete Teilnehmerreaktionen.</a:t>
+              <a:t>Selbstcheck nach 4 Wochen als Transferanker.</a:t>
             </a:r>
           </a:p>
         </p:txBody>
@@ -5035,7 +4899,7 @@
                 </a:solidFill>
                 <a:latin typeface="Arial"/>
               </a:rPr>
-              <a:t>Konditionsanpassung vorbereiten</a:t>
+              <a:t>Vom Konditionengespräch zum Wertgespräch</a:t>
             </a:r>
           </a:p>
         </p:txBody>
@@ -5061,6 +4925,25 @@
             <a:spAutoFit/>
           </a:bodyPr>
           <a:lstStyle/>
+          <a:p>
+            <a:pPr marL="177800" indent="-177800">
+              <a:spcBef>
+                <a:spcPts val="600"/>
+              </a:spcBef>
+              <a:spcAft>
+                <a:spcPts val="200"/>
+              </a:spcAft>
+            </a:pPr>
+            <a:r>
+              <a:rPr sz="1200" i="1">
+                <a:solidFill>
+                  <a:srgbClr val="3D5466"/>
+                </a:solidFill>
+                <a:latin typeface="Arial"/>
+              </a:rPr>
+              <a:t>→  Wer über Konditionen verhandelt, verliert Marge – wer über Wert spricht, verteidigt sie.</a:t>
+            </a:r>
+          </a:p>
           <a:p>
             <a:pPr marL="190500" indent="-190500">
               <a:spcBef>
@@ -5077,7 +4960,7 @@
                 </a:solidFill>
                 <a:latin typeface="Arial"/>
               </a:rPr>
-              <a:t>▸  Wenn die Analyse zeigt, dass ein Kunde unter dem Mindest-Deckungsbeitrag liegt, gibt es drei Hebel:</a:t>
+              <a:t>▸  Kundensegmentierung nach Ertragsprofil; Signale für Unterpreisierung erkennen.</a:t>
             </a:r>
           </a:p>
           <a:p>
@@ -5096,64 +4979,7 @@
                 </a:solidFill>
                 <a:latin typeface="Arial"/>
               </a:rPr>
-              <a:t>▸  Zinsmarge erhöhen: Direkte Wirkung auf DB I. Erfordert Konditionengespräch (Sec 4.4).</a:t>
-            </a:r>
-          </a:p>
-          <a:p>
-            <a:pPr marL="190500" indent="-190500">
-              <a:spcBef>
-                <a:spcPts val="400"/>
-              </a:spcBef>
-              <a:spcAft>
-                <a:spcPts val="200"/>
-              </a:spcAft>
-            </a:pPr>
-            <a:r>
-              <a:rPr sz="1300">
-                <a:solidFill>
-                  <a:srgbClr val="3D5466"/>
-                </a:solidFill>
-                <a:latin typeface="Arial"/>
-              </a:rPr>
-              <a:t>▸  Cross-Selling ausbauen: Verbundertrag und Provisionen steigern, ohne Zinskonditionen anzufassen. Oft der schonendere Weg.</a:t>
-            </a:r>
-          </a:p>
-          <a:p>
-            <a:pPr marL="190500" indent="-190500">
-              <a:spcBef>
-                <a:spcPts val="400"/>
-              </a:spcBef>
-              <a:spcAft>
-                <a:spcPts val="200"/>
-              </a:spcAft>
-            </a:pPr>
-            <a:r>
-              <a:rPr sz="1300">
-                <a:solidFill>
-                  <a:srgbClr val="3D5466"/>
-                </a:solidFill>
-                <a:latin typeface="Arial"/>
-              </a:rPr>
-              <a:t>▸  Betreuungskosten senken: Gesprächsfrequenz anpassen, digitale Kanäle stärker nutzen. Wirkt auf DB II.</a:t>
-            </a:r>
-          </a:p>
-          <a:p>
-            <a:pPr marL="190500" indent="-190500">
-              <a:spcBef>
-                <a:spcPts val="400"/>
-              </a:spcBef>
-              <a:spcAft>
-                <a:spcPts val="200"/>
-              </a:spcAft>
-            </a:pPr>
-            <a:r>
-              <a:rPr sz="1300">
-                <a:solidFill>
-                  <a:srgbClr val="3D5466"/>
-                </a:solidFill>
-                <a:latin typeface="Arial"/>
-              </a:rPr>
-              <a:t>▸  ## 4.3 Ertragsstruktur-Analyse im Bestand</a:t>
+              <a:t>▸  Das Konditionengespräch wertbasiert führen: Nutzen statt Nachlass.</a:t>
             </a:r>
           </a:p>
         </p:txBody>
@@ -5269,7 +5095,7 @@
             <a:avLst/>
           </a:prstGeom>
           <a:solidFill>
-            <a:srgbClr val="EDEDF3"/>
+            <a:srgbClr val="FFFFFF"/>
           </a:solidFill>
           <a:ln>
             <a:noFill/>
@@ -5370,51 +5196,43 @@
                 </a:solidFill>
                 <a:latin typeface="Consolas"/>
               </a:rPr>
-              <a:t>M14  ·  INHALT</a:t>
-            </a:r>
-          </a:p>
-        </p:txBody>
-      </p:sp>
-      <p:sp>
-        <p:nvSpPr>
-          <p:cNvPr id="5" name="Rectangle 4"/>
-          <p:cNvSpPr/>
-          <p:nvPr/>
-        </p:nvSpPr>
-        <p:spPr>
-          <a:xfrm>
-            <a:off x="0" y="1234440"/>
-            <a:ext cx="12188952" cy="12700"/>
-          </a:xfrm>
-          <a:prstGeom prst="rect">
-            <a:avLst/>
-          </a:prstGeom>
-          <a:solidFill>
-            <a:srgbClr val="D8DFE4"/>
-          </a:solidFill>
-          <a:ln>
-            <a:noFill/>
-          </a:ln>
-        </p:spPr>
-        <p:style>
-          <a:lnRef idx="1">
-            <a:schemeClr val="accent1"/>
-          </a:lnRef>
-          <a:fillRef idx="3">
-            <a:schemeClr val="accent1"/>
-          </a:fillRef>
-          <a:effectRef idx="2">
-            <a:schemeClr val="accent1"/>
-          </a:effectRef>
-          <a:fontRef idx="minor">
-            <a:schemeClr val="lt1"/>
-          </a:fontRef>
-        </p:style>
-        <p:txBody>
-          <a:bodyPr rtlCol="0" anchor="ctr"/>
-          <a:lstStyle/>
-          <a:p>
-            <a:pPr algn="ctr"/>
+              <a:t>M14  ·  SCHAUBILD</a:t>
+            </a:r>
+          </a:p>
+        </p:txBody>
+      </p:sp>
+      <p:sp>
+        <p:nvSpPr>
+          <p:cNvPr id="5" name="TextBox 4"/>
+          <p:cNvSpPr txBox="1"/>
+          <p:nvPr/>
+        </p:nvSpPr>
+        <p:spPr>
+          <a:xfrm>
+            <a:off x="685800" y="502920"/>
+            <a:ext cx="10817352" cy="594360"/>
+          </a:xfrm>
+          <a:prstGeom prst="rect">
+            <a:avLst/>
+          </a:prstGeom>
+          <a:noFill/>
+        </p:spPr>
+        <p:txBody>
+          <a:bodyPr wrap="square">
+            <a:spAutoFit/>
+          </a:bodyPr>
+          <a:lstStyle/>
+          <a:p>
+            <a:pPr algn="l"/>
+            <a:r>
+              <a:rPr sz="2000" b="1" i="0">
+                <a:solidFill>
+                  <a:srgbClr val="1F2C56"/>
+                </a:solidFill>
+                <a:latin typeface="Arial"/>
+              </a:rPr>
+              <a:t>Handlungsempfehlung: vom Ertragssignal zur Kondition</a:t>
+            </a:r>
           </a:p>
         </p:txBody>
       </p:sp>
@@ -5426,8 +5244,8 @@
         </p:nvSpPr>
         <p:spPr>
           <a:xfrm>
-            <a:off x="685800" y="502920"/>
-            <a:ext cx="36576" cy="658368"/>
+            <a:off x="685800" y="1143000"/>
+            <a:ext cx="10817352" cy="25400"/>
           </a:xfrm>
           <a:prstGeom prst="rect">
             <a:avLst/>
@@ -5461,143 +5279,33 @@
           </a:p>
         </p:txBody>
       </p:sp>
-      <p:sp>
-        <p:nvSpPr>
-          <p:cNvPr id="7" name="TextBox 6"/>
-          <p:cNvSpPr txBox="1"/>
-          <p:nvPr/>
-        </p:nvSpPr>
-        <p:spPr>
-          <a:xfrm>
-            <a:off x="813816" y="502920"/>
-            <a:ext cx="10634472" cy="685800"/>
-          </a:xfrm>
-          <a:prstGeom prst="rect">
-            <a:avLst/>
-          </a:prstGeom>
-          <a:noFill/>
-        </p:spPr>
-        <p:txBody>
-          <a:bodyPr wrap="square">
-            <a:spAutoFit/>
-          </a:bodyPr>
-          <a:lstStyle/>
-          <a:p>
-            <a:pPr algn="l"/>
-            <a:r>
-              <a:rPr sz="2400" b="1" i="0">
-                <a:solidFill>
-                  <a:srgbClr val="1F2C56"/>
-                </a:solidFill>
-                <a:latin typeface="Arial"/>
-              </a:rPr>
-              <a:t>Kundensegmentierung nach Ertragsprofil</a:t>
-            </a:r>
-          </a:p>
-        </p:txBody>
-      </p:sp>
-      <p:sp>
-        <p:nvSpPr>
-          <p:cNvPr id="8" name="TextBox 7"/>
-          <p:cNvSpPr txBox="1"/>
-          <p:nvPr/>
-        </p:nvSpPr>
-        <p:spPr>
-          <a:xfrm>
-            <a:off x="685800" y="1417320"/>
-            <a:ext cx="10817352" cy="4892040"/>
-          </a:xfrm>
-          <a:prstGeom prst="rect">
-            <a:avLst/>
-          </a:prstGeom>
-          <a:noFill/>
-        </p:spPr>
-        <p:txBody>
-          <a:bodyPr wrap="square" anchor="ctr">
-            <a:spAutoFit/>
-          </a:bodyPr>
-          <a:lstStyle/>
-          <a:p>
-            <a:pPr marL="190500" indent="-190500">
-              <a:spcBef>
-                <a:spcPts val="400"/>
-              </a:spcBef>
-              <a:spcAft>
-                <a:spcPts val="200"/>
-              </a:spcAft>
-            </a:pPr>
-            <a:r>
-              <a:rPr sz="1300">
-                <a:solidFill>
-                  <a:srgbClr val="3D5466"/>
-                </a:solidFill>
-                <a:latin typeface="Arial"/>
-              </a:rPr>
-              <a:t>▸  Eine einfache 2×2-Matrix hilft, den Bestand nach Ertragspotenzial und aktuellem Ertrag zu strukturieren:</a:t>
-            </a:r>
-          </a:p>
-          <a:p>
-            <a:pPr marL="190500" indent="-190500">
-              <a:spcBef>
-                <a:spcPts val="400"/>
-              </a:spcBef>
-              <a:spcAft>
-                <a:spcPts val="200"/>
-              </a:spcAft>
-            </a:pPr>
-            <a:r>
-              <a:rPr sz="1300">
-                <a:solidFill>
-                  <a:srgbClr val="3D5466"/>
-                </a:solidFill>
-                <a:latin typeface="Arial"/>
-              </a:rPr>
-              <a:t>▸  Kernkunden (hoher DB, hohes Potenzial) erhalten bevorzugte Betreuungsintensität: proaktive Kontakte, Spezialisten einbinden, Strategiegespräche.</a:t>
-            </a:r>
-          </a:p>
-          <a:p>
-            <a:pPr marL="190500" indent="-190500">
-              <a:spcBef>
-                <a:spcPts val="400"/>
-              </a:spcBef>
-              <a:spcAft>
-                <a:spcPts val="200"/>
-              </a:spcAft>
-            </a:pPr>
-            <a:r>
-              <a:rPr sz="1300">
-                <a:solidFill>
-                  <a:srgbClr val="3D5466"/>
-                </a:solidFill>
-                <a:latin typeface="Arial"/>
-              </a:rPr>
-              <a:t>▸  Entwicklungskunden (niedriger DB, hohes Potenzial) sind die Priorität für Ertragsoptimierung: Hier liegt ungenutztes Wallet-Share-Potenzial.</a:t>
-            </a:r>
-          </a:p>
-          <a:p>
-            <a:pPr marL="190500" indent="-190500">
-              <a:spcBef>
-                <a:spcPts val="400"/>
-              </a:spcBef>
-              <a:spcAft>
-                <a:spcPts val="200"/>
-              </a:spcAft>
-            </a:pPr>
-            <a:r>
-              <a:rPr sz="1300">
-                <a:solidFill>
-                  <a:srgbClr val="3D5466"/>
-                </a:solidFill>
-                <a:latin typeface="Arial"/>
-              </a:rPr>
-              <a:t>▸  Problemkunden (niedriger DB, niedriges Potenzial) sollten mit minimalem Aufwand betreut werden. Exit aus der Beziehung ist bei dauerhaft negativem DB zu prüfen – aber:</a:t>
-            </a:r>
-          </a:p>
-        </p:txBody>
-      </p:sp>
-      <p:sp>
-        <p:nvSpPr>
-          <p:cNvPr id="9" name="Rectangle 8"/>
+      <p:pic>
+        <p:nvPicPr>
+          <p:cNvPr id="7" name="Picture 6" descr="image.png"/>
+          <p:cNvPicPr>
+            <a:picLocks noChangeAspect="1"/>
+          </p:cNvPicPr>
+          <p:nvPr/>
+        </p:nvPicPr>
+        <p:blipFill>
+          <a:blip r:embed="rId2"/>
+          <a:stretch>
+            <a:fillRect/>
+          </a:stretch>
+        </p:blipFill>
+        <p:spPr>
+          <a:xfrm>
+            <a:off x="2303489" y="1325880"/>
+            <a:ext cx="7581973" cy="4937760"/>
+          </a:xfrm>
+          <a:prstGeom prst="rect">
+            <a:avLst/>
+          </a:prstGeom>
+        </p:spPr>
+      </p:pic>
+      <p:sp>
+        <p:nvSpPr>
+          <p:cNvPr id="8" name="Rectangle 7"/>
           <p:cNvSpPr/>
           <p:nvPr/>
         </p:nvSpPr>
@@ -5640,7 +5348,7 @@
       </p:sp>
       <p:sp>
         <p:nvSpPr>
-          <p:cNvPr id="10" name="TextBox 9"/>
+          <p:cNvPr id="9" name="TextBox 8"/>
           <p:cNvSpPr txBox="1"/>
           <p:nvPr/>
         </p:nvSpPr>
@@ -5669,6 +5377,41 @@
                 <a:latin typeface="Consolas"/>
               </a:rPr>
               <a:t>FKB Campus  ·  M14</a:t>
+            </a:r>
+          </a:p>
+        </p:txBody>
+      </p:sp>
+      <p:sp>
+        <p:nvSpPr>
+          <p:cNvPr id="10" name="TextBox 9"/>
+          <p:cNvSpPr txBox="1"/>
+          <p:nvPr/>
+        </p:nvSpPr>
+        <p:spPr>
+          <a:xfrm>
+            <a:off x="7176211" y="6583680"/>
+            <a:ext cx="4326940" cy="256032"/>
+          </a:xfrm>
+          <a:prstGeom prst="rect">
+            <a:avLst/>
+          </a:prstGeom>
+          <a:noFill/>
+        </p:spPr>
+        <p:txBody>
+          <a:bodyPr wrap="none">
+            <a:spAutoFit/>
+          </a:bodyPr>
+          <a:lstStyle/>
+          <a:p>
+            <a:pPr algn="r"/>
+            <a:r>
+              <a:rPr sz="700">
+                <a:solidFill>
+                  <a:srgbClr val="A0B4D2"/>
+                </a:solidFill>
+                <a:latin typeface="Consolas"/>
+              </a:rPr>
+              <a:t>Schaubild</a:t>
             </a:r>
           </a:p>
         </p:txBody>
@@ -5706,7 +5449,7 @@
             <a:avLst/>
           </a:prstGeom>
           <a:solidFill>
-            <a:srgbClr val="EDEDF3"/>
+            <a:srgbClr val="1F2C56"/>
           </a:solidFill>
           <a:ln>
             <a:noFill/>
@@ -5736,57 +5479,14 @@
       </p:sp>
       <p:sp>
         <p:nvSpPr>
-          <p:cNvPr id="3" name="Rectangle 2"/>
-          <p:cNvSpPr/>
-          <p:nvPr/>
-        </p:nvSpPr>
-        <p:spPr>
-          <a:xfrm>
-            <a:off x="0" y="0"/>
-            <a:ext cx="12188952" cy="50292"/>
-          </a:xfrm>
-          <a:prstGeom prst="rect">
-            <a:avLst/>
-          </a:prstGeom>
-          <a:solidFill>
-            <a:srgbClr val="1F2C56"/>
-          </a:solidFill>
-          <a:ln>
-            <a:noFill/>
-          </a:ln>
-        </p:spPr>
-        <p:style>
-          <a:lnRef idx="1">
-            <a:schemeClr val="accent1"/>
-          </a:lnRef>
-          <a:fillRef idx="3">
-            <a:schemeClr val="accent1"/>
-          </a:fillRef>
-          <a:effectRef idx="2">
-            <a:schemeClr val="accent1"/>
-          </a:effectRef>
-          <a:fontRef idx="minor">
-            <a:schemeClr val="lt1"/>
-          </a:fontRef>
-        </p:style>
-        <p:txBody>
-          <a:bodyPr rtlCol="0" anchor="ctr"/>
-          <a:lstStyle/>
-          <a:p>
-            <a:pPr algn="ctr"/>
-          </a:p>
-        </p:txBody>
-      </p:sp>
-      <p:sp>
-        <p:nvSpPr>
-          <p:cNvPr id="4" name="TextBox 3"/>
+          <p:cNvPr id="3" name="TextBox 2"/>
           <p:cNvSpPr txBox="1"/>
           <p:nvPr/>
         </p:nvSpPr>
         <p:spPr>
           <a:xfrm>
-            <a:off x="685800" y="109728"/>
-            <a:ext cx="10817352" cy="228600"/>
+            <a:off x="685800" y="2377440"/>
+            <a:ext cx="10817352" cy="365760"/>
           </a:xfrm>
           <a:prstGeom prst="rect">
             <a:avLst/>
@@ -5801,70 +5501,27 @@
           <a:p>
             <a:pPr algn="l"/>
             <a:r>
-              <a:rPr sz="750">
-                <a:solidFill>
-                  <a:srgbClr val="78808C"/>
+              <a:rPr sz="1200">
+                <a:solidFill>
+                  <a:srgbClr val="D9C089"/>
                 </a:solidFill>
                 <a:latin typeface="Consolas"/>
               </a:rPr>
-              <a:t>M14  ·  INHALT</a:t>
-            </a:r>
-          </a:p>
-        </p:txBody>
-      </p:sp>
-      <p:sp>
-        <p:nvSpPr>
-          <p:cNvPr id="5" name="Rectangle 4"/>
+              <a:t>FALLARBEIT</a:t>
+            </a:r>
+          </a:p>
+        </p:txBody>
+      </p:sp>
+      <p:sp>
+        <p:nvSpPr>
+          <p:cNvPr id="4" name="Rectangle 3"/>
           <p:cNvSpPr/>
           <p:nvPr/>
         </p:nvSpPr>
         <p:spPr>
           <a:xfrm>
-            <a:off x="0" y="1234440"/>
-            <a:ext cx="12188952" cy="12700"/>
-          </a:xfrm>
-          <a:prstGeom prst="rect">
-            <a:avLst/>
-          </a:prstGeom>
-          <a:solidFill>
-            <a:srgbClr val="D8DFE4"/>
-          </a:solidFill>
-          <a:ln>
-            <a:noFill/>
-          </a:ln>
-        </p:spPr>
-        <p:style>
-          <a:lnRef idx="1">
-            <a:schemeClr val="accent1"/>
-          </a:lnRef>
-          <a:fillRef idx="3">
-            <a:schemeClr val="accent1"/>
-          </a:fillRef>
-          <a:effectRef idx="2">
-            <a:schemeClr val="accent1"/>
-          </a:effectRef>
-          <a:fontRef idx="minor">
-            <a:schemeClr val="lt1"/>
-          </a:fontRef>
-        </p:style>
-        <p:txBody>
-          <a:bodyPr rtlCol="0" anchor="ctr"/>
-          <a:lstStyle/>
-          <a:p>
-            <a:pPr algn="ctr"/>
-          </a:p>
-        </p:txBody>
-      </p:sp>
-      <p:sp>
-        <p:nvSpPr>
-          <p:cNvPr id="6" name="Rectangle 5"/>
-          <p:cNvSpPr/>
-          <p:nvPr/>
-        </p:nvSpPr>
-        <p:spPr>
-          <a:xfrm>
-            <a:off x="685800" y="502920"/>
-            <a:ext cx="36576" cy="658368"/>
+            <a:off x="685800" y="2788920"/>
+            <a:ext cx="548640" cy="38100"/>
           </a:xfrm>
           <a:prstGeom prst="rect">
             <a:avLst/>
@@ -5900,14 +5557,14 @@
       </p:sp>
       <p:sp>
         <p:nvSpPr>
-          <p:cNvPr id="7" name="TextBox 6"/>
+          <p:cNvPr id="5" name="TextBox 4"/>
           <p:cNvSpPr txBox="1"/>
           <p:nvPr/>
         </p:nvSpPr>
         <p:spPr>
           <a:xfrm>
-            <a:off x="813816" y="502920"/>
-            <a:ext cx="10634472" cy="685800"/>
+            <a:off x="685800" y="3017520"/>
+            <a:ext cx="10817352" cy="1463040"/>
           </a:xfrm>
           <a:prstGeom prst="rect">
             <a:avLst/>
@@ -5922,27 +5579,27 @@
           <a:p>
             <a:pPr algn="l"/>
             <a:r>
-              <a:rPr sz="2400" b="1" i="0">
-                <a:solidFill>
-                  <a:srgbClr val="1F2C56"/>
+              <a:rPr sz="4000" b="1" i="0">
+                <a:solidFill>
+                  <a:srgbClr val="FFFFFF"/>
                 </a:solidFill>
                 <a:latin typeface="Arial"/>
               </a:rPr>
-              <a:t>Signale für Unterpreisierung</a:t>
-            </a:r>
-          </a:p>
-        </p:txBody>
-      </p:sp>
-      <p:sp>
-        <p:nvSpPr>
-          <p:cNvPr id="8" name="TextBox 7"/>
+              <a:t>Praxiscase Bauer &amp; Söhne</a:t>
+            </a:r>
+          </a:p>
+        </p:txBody>
+      </p:sp>
+      <p:sp>
+        <p:nvSpPr>
+          <p:cNvPr id="6" name="TextBox 5"/>
           <p:cNvSpPr txBox="1"/>
           <p:nvPr/>
         </p:nvSpPr>
         <p:spPr>
           <a:xfrm>
-            <a:off x="685800" y="1417320"/>
-            <a:ext cx="10817352" cy="4892040"/>
+            <a:off x="685800" y="4480560"/>
+            <a:ext cx="8653881" cy="1280160"/>
           </a:xfrm>
           <a:prstGeom prst="rect">
             <a:avLst/>
@@ -5955,193 +5612,29 @@
           </a:bodyPr>
           <a:lstStyle/>
           <a:p>
-            <a:pPr marL="190500" indent="-190500">
-              <a:spcBef>
-                <a:spcPts val="400"/>
-              </a:spcBef>
-              <a:spcAft>
-                <a:spcPts val="200"/>
-              </a:spcAft>
-            </a:pPr>
-            <a:r>
-              <a:rPr sz="1300">
-                <a:solidFill>
-                  <a:srgbClr val="3D5466"/>
+            <a:pPr algn="l"/>
+            <a:r>
+              <a:rPr sz="1600" b="0" i="0">
+                <a:solidFill>
+                  <a:srgbClr val="C8D2E6"/>
                 </a:solidFill>
                 <a:latin typeface="Arial"/>
               </a:rPr>
-              <a:t>▸  Berater erkennen unterpreiste Engagements oft an folgenden Signalen:</a:t>
-            </a:r>
-          </a:p>
-          <a:p>
-            <a:pPr marL="190500" indent="-190500">
-              <a:spcBef>
-                <a:spcPts val="400"/>
-              </a:spcBef>
-              <a:spcAft>
-                <a:spcPts val="200"/>
-              </a:spcAft>
-            </a:pPr>
-            <a:r>
-              <a:rPr sz="1300">
-                <a:solidFill>
-                  <a:srgbClr val="3D5466"/>
-                </a:solidFill>
-                <a:latin typeface="Arial"/>
-              </a:rPr>
-              <a:t>▸  Kreditmarge liegt deutlich unter Marktüblichkeit (Benchmarkcheck in agree)</a:t>
-            </a:r>
-          </a:p>
-          <a:p>
-            <a:pPr marL="190500" indent="-190500">
-              <a:spcBef>
-                <a:spcPts val="400"/>
-              </a:spcBef>
-              <a:spcAft>
-                <a:spcPts val="200"/>
-              </a:spcAft>
-            </a:pPr>
-            <a:r>
-              <a:rPr sz="1300">
-                <a:solidFill>
-                  <a:srgbClr val="3D5466"/>
-                </a:solidFill>
-                <a:latin typeface="Arial"/>
-              </a:rPr>
-              <a:t>▸  Kein Verbundpartner eingebunden, obwohl Potenzial vorhanden</a:t>
-            </a:r>
-          </a:p>
-          <a:p>
-            <a:pPr marL="190500" indent="-190500">
-              <a:spcBef>
-                <a:spcPts val="400"/>
-              </a:spcBef>
-              <a:spcAft>
-                <a:spcPts val="200"/>
-              </a:spcAft>
-            </a:pPr>
-            <a:r>
-              <a:rPr sz="1300">
-                <a:solidFill>
-                  <a:srgbClr val="3D5466"/>
-                </a:solidFill>
-                <a:latin typeface="Arial"/>
-              </a:rPr>
-              <a:t>▸  Hohe Inanspruchnahme offener Linien → steigt EAD, Marge wurde nie angepasst</a:t>
-            </a:r>
-          </a:p>
-          <a:p>
-            <a:pPr marL="190500" indent="-190500">
-              <a:spcBef>
-                <a:spcPts val="400"/>
-              </a:spcBef>
-              <a:spcAft>
-                <a:spcPts val="200"/>
-              </a:spcAft>
-            </a:pPr>
-            <a:r>
-              <a:rPr sz="1300">
-                <a:solidFill>
-                  <a:srgbClr val="3D5466"/>
-                </a:solidFill>
-                <a:latin typeface="Arial"/>
-              </a:rPr>
-              <a:t>▸  Ratingverschlechterung ohne Konditionsanpassung → EL gestiegen, Marge unverändert</a:t>
-            </a:r>
-          </a:p>
-          <a:p>
-            <a:pPr marL="190500" indent="-190500">
-              <a:spcBef>
-                <a:spcPts val="400"/>
-              </a:spcBef>
-              <a:spcAft>
-                <a:spcPts val="200"/>
-              </a:spcAft>
-            </a:pPr>
-            <a:r>
-              <a:rPr sz="1300">
-                <a:solidFill>
-                  <a:srgbClr val="3D5466"/>
-                </a:solidFill>
-                <a:latin typeface="Arial"/>
-              </a:rPr>
-              <a:t>▸  Die folgende Handlungsempfehlung-Karte verknüpft diese Ertragssignale mit dem jeweils passenden Vertriebsimpuls:</a:t>
-            </a:r>
-          </a:p>
-          <a:p>
-            <a:pPr marL="190500" indent="-190500">
-              <a:spcBef>
-                <a:spcPts val="400"/>
-              </a:spcBef>
-              <a:spcAft>
-                <a:spcPts val="200"/>
-              </a:spcAft>
-            </a:pPr>
-            <a:r>
-              <a:rPr sz="1300">
-                <a:solidFill>
-                  <a:srgbClr val="3D5466"/>
-                </a:solidFill>
-                <a:latin typeface="Arial"/>
-              </a:rPr>
-              <a:t>▸  ## 4.4 Das Konditionengespräch wertbasiert führen</a:t>
-            </a:r>
-          </a:p>
-        </p:txBody>
-      </p:sp>
-      <p:sp>
-        <p:nvSpPr>
-          <p:cNvPr id="9" name="Rectangle 8"/>
-          <p:cNvSpPr/>
-          <p:nvPr/>
-        </p:nvSpPr>
-        <p:spPr>
-          <a:xfrm>
-            <a:off x="0" y="6510528"/>
-            <a:ext cx="12188952" cy="347472"/>
-          </a:xfrm>
-          <a:prstGeom prst="rect">
-            <a:avLst/>
-          </a:prstGeom>
-          <a:solidFill>
-            <a:srgbClr val="0A1937"/>
-          </a:solidFill>
-          <a:ln>
-            <a:noFill/>
-          </a:ln>
-        </p:spPr>
-        <p:style>
-          <a:lnRef idx="1">
-            <a:schemeClr val="accent1"/>
-          </a:lnRef>
-          <a:fillRef idx="3">
-            <a:schemeClr val="accent1"/>
-          </a:fillRef>
-          <a:effectRef idx="2">
-            <a:schemeClr val="accent1"/>
-          </a:effectRef>
-          <a:fontRef idx="minor">
-            <a:schemeClr val="lt1"/>
-          </a:fontRef>
-        </p:style>
-        <p:txBody>
-          <a:bodyPr rtlCol="0" anchor="ctr"/>
-          <a:lstStyle/>
-          <a:p>
-            <a:pPr algn="ctr"/>
-          </a:p>
-        </p:txBody>
-      </p:sp>
-      <p:sp>
-        <p:nvSpPr>
-          <p:cNvPr id="10" name="TextBox 9"/>
+              <a:t>Die Ertragsstruktur eines Kunden analysieren und ein Wertgespräch vorbereiten.</a:t>
+            </a:r>
+          </a:p>
+        </p:txBody>
+      </p:sp>
+      <p:sp>
+        <p:nvSpPr>
+          <p:cNvPr id="7" name="TextBox 6"/>
           <p:cNvSpPr txBox="1"/>
           <p:nvPr/>
         </p:nvSpPr>
         <p:spPr>
           <a:xfrm>
-            <a:off x="685800" y="6583680"/>
-            <a:ext cx="6490411" cy="256032"/>
+            <a:off x="685800" y="6355080"/>
+            <a:ext cx="10817352" cy="274320"/>
           </a:xfrm>
           <a:prstGeom prst="rect">
             <a:avLst/>
@@ -6158,7 +5651,7 @@
             <a:r>
               <a:rPr sz="700">
                 <a:solidFill>
-                  <a:srgbClr val="A0B4D2"/>
+                  <a:srgbClr val="8CA0C3"/>
                 </a:solidFill>
                 <a:latin typeface="Consolas"/>
               </a:rPr>
@@ -6200,7 +5693,7 @@
             <a:avLst/>
           </a:prstGeom>
           <a:solidFill>
-            <a:srgbClr val="FFFFFF"/>
+            <a:srgbClr val="EDEDF3"/>
           </a:solidFill>
           <a:ln>
             <a:noFill/>
@@ -6301,43 +5794,51 @@
                 </a:solidFill>
                 <a:latin typeface="Consolas"/>
               </a:rPr>
-              <a:t>M14  ·  SCHAUBILD</a:t>
-            </a:r>
-          </a:p>
-        </p:txBody>
-      </p:sp>
-      <p:sp>
-        <p:nvSpPr>
-          <p:cNvPr id="5" name="TextBox 4"/>
-          <p:cNvSpPr txBox="1"/>
-          <p:nvPr/>
-        </p:nvSpPr>
-        <p:spPr>
-          <a:xfrm>
-            <a:off x="685800" y="502920"/>
-            <a:ext cx="10817352" cy="594360"/>
-          </a:xfrm>
-          <a:prstGeom prst="rect">
-            <a:avLst/>
-          </a:prstGeom>
-          <a:noFill/>
-        </p:spPr>
-        <p:txBody>
-          <a:bodyPr wrap="square">
-            <a:spAutoFit/>
-          </a:bodyPr>
-          <a:lstStyle/>
-          <a:p>
-            <a:pPr algn="l"/>
-            <a:r>
-              <a:rPr sz="2000" b="1" i="0">
-                <a:solidFill>
-                  <a:srgbClr val="1F2C56"/>
-                </a:solidFill>
-                <a:latin typeface="Arial"/>
-              </a:rPr>
-              <a:t>Handlungsempfehlung</a:t>
-            </a:r>
+              <a:t>M14  ·  ARBEITSBLATT</a:t>
+            </a:r>
+          </a:p>
+        </p:txBody>
+      </p:sp>
+      <p:sp>
+        <p:nvSpPr>
+          <p:cNvPr id="5" name="Rectangle 4"/>
+          <p:cNvSpPr/>
+          <p:nvPr/>
+        </p:nvSpPr>
+        <p:spPr>
+          <a:xfrm>
+            <a:off x="0" y="1234440"/>
+            <a:ext cx="12188952" cy="12700"/>
+          </a:xfrm>
+          <a:prstGeom prst="rect">
+            <a:avLst/>
+          </a:prstGeom>
+          <a:solidFill>
+            <a:srgbClr val="D8DFE4"/>
+          </a:solidFill>
+          <a:ln>
+            <a:noFill/>
+          </a:ln>
+        </p:spPr>
+        <p:style>
+          <a:lnRef idx="1">
+            <a:schemeClr val="accent1"/>
+          </a:lnRef>
+          <a:fillRef idx="3">
+            <a:schemeClr val="accent1"/>
+          </a:fillRef>
+          <a:effectRef idx="2">
+            <a:schemeClr val="accent1"/>
+          </a:effectRef>
+          <a:fontRef idx="minor">
+            <a:schemeClr val="lt1"/>
+          </a:fontRef>
+        </p:style>
+        <p:txBody>
+          <a:bodyPr rtlCol="0" anchor="ctr"/>
+          <a:lstStyle/>
+          <a:p>
+            <a:pPr algn="ctr"/>
           </a:p>
         </p:txBody>
       </p:sp>
@@ -6349,8 +5850,8 @@
         </p:nvSpPr>
         <p:spPr>
           <a:xfrm>
-            <a:off x="685800" y="1143000"/>
-            <a:ext cx="10817352" cy="25400"/>
+            <a:off x="685800" y="502920"/>
+            <a:ext cx="36576" cy="658368"/>
           </a:xfrm>
           <a:prstGeom prst="rect">
             <a:avLst/>
@@ -6384,33 +5885,202 @@
           </a:p>
         </p:txBody>
       </p:sp>
-      <p:pic>
-        <p:nvPicPr>
-          <p:cNvPr id="7" name="Picture 6" descr="image.png"/>
-          <p:cNvPicPr>
-            <a:picLocks noChangeAspect="1"/>
-          </p:cNvPicPr>
-          <p:nvPr/>
-        </p:nvPicPr>
-        <p:blipFill>
-          <a:blip r:embed="rId2"/>
-          <a:stretch>
-            <a:fillRect/>
-          </a:stretch>
-        </p:blipFill>
-        <p:spPr>
-          <a:xfrm>
-            <a:off x="2303489" y="1325880"/>
-            <a:ext cx="7581973" cy="4937760"/>
-          </a:xfrm>
-          <a:prstGeom prst="rect">
-            <a:avLst/>
-          </a:prstGeom>
-        </p:spPr>
-      </p:pic>
-      <p:sp>
-        <p:nvSpPr>
-          <p:cNvPr id="8" name="Rectangle 7"/>
+      <p:sp>
+        <p:nvSpPr>
+          <p:cNvPr id="7" name="TextBox 6"/>
+          <p:cNvSpPr txBox="1"/>
+          <p:nvPr/>
+        </p:nvSpPr>
+        <p:spPr>
+          <a:xfrm>
+            <a:off x="813816" y="502920"/>
+            <a:ext cx="10634472" cy="685800"/>
+          </a:xfrm>
+          <a:prstGeom prst="rect">
+            <a:avLst/>
+          </a:prstGeom>
+          <a:noFill/>
+        </p:spPr>
+        <p:txBody>
+          <a:bodyPr wrap="square">
+            <a:spAutoFit/>
+          </a:bodyPr>
+          <a:lstStyle/>
+          <a:p>
+            <a:pPr algn="l"/>
+            <a:r>
+              <a:rPr sz="2400" b="1" i="0">
+                <a:solidFill>
+                  <a:srgbClr val="1F2C56"/>
+                </a:solidFill>
+                <a:latin typeface="Arial"/>
+              </a:rPr>
+              <a:t>Ertragsanalyse Bauer &amp; Söhne bearbeiten</a:t>
+            </a:r>
+          </a:p>
+        </p:txBody>
+      </p:sp>
+      <p:sp>
+        <p:nvSpPr>
+          <p:cNvPr id="8" name="TextBox 7"/>
+          <p:cNvSpPr txBox="1"/>
+          <p:nvPr/>
+        </p:nvSpPr>
+        <p:spPr>
+          <a:xfrm>
+            <a:off x="685800" y="1554480"/>
+            <a:ext cx="10817352" cy="3840480"/>
+          </a:xfrm>
+          <a:prstGeom prst="rect">
+            <a:avLst/>
+          </a:prstGeom>
+          <a:noFill/>
+        </p:spPr>
+        <p:txBody>
+          <a:bodyPr wrap="square">
+            <a:spAutoFit/>
+          </a:bodyPr>
+          <a:lstStyle/>
+          <a:p>
+            <a:pPr marL="190500" indent="-190500">
+              <a:spcBef>
+                <a:spcPts val="400"/>
+              </a:spcBef>
+              <a:spcAft>
+                <a:spcPts val="200"/>
+              </a:spcAft>
+            </a:pPr>
+            <a:r>
+              <a:rPr sz="1400">
+                <a:solidFill>
+                  <a:srgbClr val="3D5466"/>
+                </a:solidFill>
+                <a:latin typeface="Arial"/>
+              </a:rPr>
+              <a:t>▸  Erstellen Sie die Deckungsbeitragsrechnung für Bauer &amp; Söhne (AB-1) mit dem XLSX-Modell.</a:t>
+            </a:r>
+          </a:p>
+          <a:p>
+            <a:pPr marL="190500" indent="-190500">
+              <a:spcBef>
+                <a:spcPts val="400"/>
+              </a:spcBef>
+              <a:spcAft>
+                <a:spcPts val="200"/>
+              </a:spcAft>
+            </a:pPr>
+            <a:r>
+              <a:rPr sz="1400">
+                <a:solidFill>
+                  <a:srgbClr val="3D5466"/>
+                </a:solidFill>
+                <a:latin typeface="Arial"/>
+              </a:rPr>
+              <a:t>▸  Berechnen Sie Expected Loss und Kundenrendite und erkennen Sie die Unterpreisierung.</a:t>
+            </a:r>
+          </a:p>
+          <a:p>
+            <a:pPr marL="190500" indent="-190500">
+              <a:spcBef>
+                <a:spcPts val="400"/>
+              </a:spcBef>
+              <a:spcAft>
+                <a:spcPts val="200"/>
+              </a:spcAft>
+            </a:pPr>
+            <a:r>
+              <a:rPr sz="1400">
+                <a:solidFill>
+                  <a:srgbClr val="3D5466"/>
+                </a:solidFill>
+                <a:latin typeface="Arial"/>
+              </a:rPr>
+              <a:t>▸  Bereiten Sie ein wertbasiertes Konditionengespräch vor (AB-2).</a:t>
+            </a:r>
+          </a:p>
+        </p:txBody>
+      </p:sp>
+      <p:sp>
+        <p:nvSpPr>
+          <p:cNvPr id="9" name="Rectangle 8"/>
+          <p:cNvSpPr/>
+          <p:nvPr/>
+        </p:nvSpPr>
+        <p:spPr>
+          <a:xfrm>
+            <a:off x="685800" y="5486400"/>
+            <a:ext cx="10817352" cy="640080"/>
+          </a:xfrm>
+          <a:prstGeom prst="rect">
+            <a:avLst/>
+          </a:prstGeom>
+          <a:solidFill>
+            <a:srgbClr val="1F2C56"/>
+          </a:solidFill>
+          <a:ln>
+            <a:noFill/>
+          </a:ln>
+        </p:spPr>
+        <p:style>
+          <a:lnRef idx="1">
+            <a:schemeClr val="accent1"/>
+          </a:lnRef>
+          <a:fillRef idx="3">
+            <a:schemeClr val="accent1"/>
+          </a:fillRef>
+          <a:effectRef idx="2">
+            <a:schemeClr val="accent1"/>
+          </a:effectRef>
+          <a:fontRef idx="minor">
+            <a:schemeClr val="lt1"/>
+          </a:fontRef>
+        </p:style>
+        <p:txBody>
+          <a:bodyPr rtlCol="0" anchor="ctr"/>
+          <a:lstStyle/>
+          <a:p>
+            <a:pPr algn="ctr"/>
+          </a:p>
+        </p:txBody>
+      </p:sp>
+      <p:sp>
+        <p:nvSpPr>
+          <p:cNvPr id="10" name="TextBox 9"/>
+          <p:cNvSpPr txBox="1"/>
+          <p:nvPr/>
+        </p:nvSpPr>
+        <p:spPr>
+          <a:xfrm>
+            <a:off x="868680" y="5596128"/>
+            <a:ext cx="10451592" cy="457200"/>
+          </a:xfrm>
+          <a:prstGeom prst="rect">
+            <a:avLst/>
+          </a:prstGeom>
+          <a:noFill/>
+        </p:spPr>
+        <p:txBody>
+          <a:bodyPr wrap="square">
+            <a:spAutoFit/>
+          </a:bodyPr>
+          <a:lstStyle/>
+          <a:p>
+            <a:pPr algn="l"/>
+            <a:r>
+              <a:rPr sz="1300" b="1" i="0">
+                <a:solidFill>
+                  <a:srgbClr val="FFFFFF"/>
+                </a:solidFill>
+                <a:latin typeface="Arial"/>
+              </a:rPr>
+              <a:t>→  Bearbeitung im Teilnehmer-Workbook (Arbeitsblatt mit Ausfüllfeldern)</a:t>
+            </a:r>
+          </a:p>
+        </p:txBody>
+      </p:sp>
+      <p:sp>
+        <p:nvSpPr>
+          <p:cNvPr id="11" name="Rectangle 10"/>
           <p:cNvSpPr/>
           <p:nvPr/>
         </p:nvSpPr>
@@ -6453,7 +6123,7 @@
       </p:sp>
       <p:sp>
         <p:nvSpPr>
-          <p:cNvPr id="9" name="TextBox 8"/>
+          <p:cNvPr id="12" name="TextBox 11"/>
           <p:cNvSpPr txBox="1"/>
           <p:nvPr/>
         </p:nvSpPr>
@@ -6482,41 +6152,6 @@
                 <a:latin typeface="Consolas"/>
               </a:rPr>
               <a:t>FKB Campus  ·  M14</a:t>
-            </a:r>
-          </a:p>
-        </p:txBody>
-      </p:sp>
-      <p:sp>
-        <p:nvSpPr>
-          <p:cNvPr id="10" name="TextBox 9"/>
-          <p:cNvSpPr txBox="1"/>
-          <p:nvPr/>
-        </p:nvSpPr>
-        <p:spPr>
-          <a:xfrm>
-            <a:off x="7176211" y="6583680"/>
-            <a:ext cx="4326940" cy="256032"/>
-          </a:xfrm>
-          <a:prstGeom prst="rect">
-            <a:avLst/>
-          </a:prstGeom>
-          <a:noFill/>
-        </p:spPr>
-        <p:txBody>
-          <a:bodyPr wrap="none">
-            <a:spAutoFit/>
-          </a:bodyPr>
-          <a:lstStyle/>
-          <a:p>
-            <a:pPr algn="r"/>
-            <a:r>
-              <a:rPr sz="700">
-                <a:solidFill>
-                  <a:srgbClr val="A0B4D2"/>
-                </a:solidFill>
-                <a:latin typeface="Consolas"/>
-              </a:rPr>
-              <a:t>Schaubild</a:t>
             </a:r>
           </a:p>
         </p:txBody>
@@ -6776,7 +6411,7 @@
                 </a:solidFill>
                 <a:latin typeface="Arial"/>
               </a:rPr>
-              <a:t>Vom Konditionengespräch zum Wertgespräch</a:t>
+              <a:t>Prinzip dieses Moduls</a:t>
             </a:r>
           </a:p>
         </p:txBody>
@@ -6798,10 +6433,29 @@
           <a:noFill/>
         </p:spPr>
         <p:txBody>
-          <a:bodyPr wrap="square">
+          <a:bodyPr wrap="square" anchor="ctr">
             <a:spAutoFit/>
           </a:bodyPr>
           <a:lstStyle/>
+          <a:p>
+            <a:pPr marL="177800" indent="-177800">
+              <a:spcBef>
+                <a:spcPts val="600"/>
+              </a:spcBef>
+              <a:spcAft>
+                <a:spcPts val="200"/>
+              </a:spcAft>
+            </a:pPr>
+            <a:r>
+              <a:rPr sz="1200" i="1">
+                <a:solidFill>
+                  <a:srgbClr val="3D5466"/>
+                </a:solidFill>
+                <a:latin typeface="Arial"/>
+              </a:rPr>
+              <a:t>→  Nicht das Volumen zählt, sondern der Deckungsbeitrag.</a:t>
+            </a:r>
+          </a:p>
           <a:p>
             <a:pPr marL="190500" indent="-190500">
               <a:spcBef>
@@ -6818,216 +6472,7 @@
                 </a:solidFill>
                 <a:latin typeface="Arial"/>
               </a:rPr>
-              <a:t>▸  Ein wertbasierter Ansatz kehrt die Reihenfolge um:</a:t>
-            </a:r>
-          </a:p>
-          <a:p>
-            <a:pPr marL="190500" indent="-190500">
-              <a:spcBef>
-                <a:spcPts val="400"/>
-              </a:spcBef>
-              <a:spcAft>
-                <a:spcPts val="200"/>
-              </a:spcAft>
-            </a:pPr>
-            <a:r>
-              <a:rPr sz="1300">
-                <a:solidFill>
-                  <a:srgbClr val="3D5466"/>
-                </a:solidFill>
-                <a:latin typeface="Arial"/>
-              </a:rPr>
-              <a:t>▸  Phase 1: Wert der Beziehung artikulieren</a:t>
-            </a:r>
-          </a:p>
-          <a:p>
-            <a:pPr marL="190500" indent="-190500">
-              <a:spcBef>
-                <a:spcPts val="400"/>
-              </a:spcBef>
-              <a:spcAft>
-                <a:spcPts val="200"/>
-              </a:spcAft>
-            </a:pPr>
-            <a:r>
-              <a:rPr sz="1300">
-                <a:solidFill>
-                  <a:srgbClr val="3D5466"/>
-                </a:solidFill>
-                <a:latin typeface="Arial"/>
-              </a:rPr>
-              <a:t>▸  Phase 2: Marktumfeld erklären</a:t>
-            </a:r>
-          </a:p>
-          <a:p>
-            <a:pPr marL="190500" indent="-190500">
-              <a:spcBef>
-                <a:spcPts val="400"/>
-              </a:spcBef>
-              <a:spcAft>
-                <a:spcPts val="200"/>
-              </a:spcAft>
-            </a:pPr>
-            <a:r>
-              <a:rPr sz="1300">
-                <a:solidFill>
-                  <a:srgbClr val="3D5466"/>
-                </a:solidFill>
-                <a:latin typeface="Arial"/>
-              </a:rPr>
-              <a:t>▸  Zinsentwicklung, Refinanzierungskosten, Risikoumfeld transparent machen – ohne Details zu internen Kalkulationen preiszugeben.</a:t>
-            </a:r>
-          </a:p>
-          <a:p>
-            <a:pPr marL="190500" indent="-190500">
-              <a:spcBef>
-                <a:spcPts val="400"/>
-              </a:spcBef>
-              <a:spcAft>
-                <a:spcPts val="200"/>
-              </a:spcAft>
-            </a:pPr>
-            <a:r>
-              <a:rPr sz="1300">
-                <a:solidFill>
-                  <a:srgbClr val="3D5466"/>
-                </a:solidFill>
-                <a:latin typeface="Arial"/>
-              </a:rPr>
-              <a:t>▸  Phase 3: Konditionen transparent kommunizieren</a:t>
-            </a:r>
-          </a:p>
-          <a:p>
-            <a:pPr marL="190500" indent="-190500">
-              <a:spcBef>
-                <a:spcPts val="400"/>
-              </a:spcBef>
-              <a:spcAft>
-                <a:spcPts val="200"/>
-              </a:spcAft>
-            </a:pPr>
-            <a:r>
-              <a:rPr sz="1300">
-                <a:solidFill>
-                  <a:srgbClr val="3D5466"/>
-                </a:solidFill>
-                <a:latin typeface="Arial"/>
-              </a:rPr>
-              <a:t>▸  Phase 4: Alternativen anbieten</a:t>
-            </a:r>
-          </a:p>
-          <a:p>
-            <a:pPr marL="190500" indent="-190500">
-              <a:spcBef>
-                <a:spcPts val="400"/>
-              </a:spcBef>
-              <a:spcAft>
-                <a:spcPts val="200"/>
-              </a:spcAft>
-            </a:pPr>
-            <a:r>
-              <a:rPr sz="1300">
-                <a:solidFill>
-                  <a:srgbClr val="3D5466"/>
-                </a:solidFill>
-                <a:latin typeface="Arial"/>
-              </a:rPr>
-              <a:t>▸  Dem Kunden Optionen geben: „Wenn wir die Besicherung verbessern, könnten wir bei der Marge etwas flexibler sein." Oder: „Wenn Sie das R+V-Paket hinzunehmen, sehen wir die Gesamtbeziehung anders."</a:t>
-            </a:r>
-          </a:p>
-          <a:p>
-            <a:pPr marL="190500" indent="-190500">
-              <a:spcBef>
-                <a:spcPts val="400"/>
-              </a:spcBef>
-              <a:spcAft>
-                <a:spcPts val="200"/>
-              </a:spcAft>
-            </a:pPr>
-            <a:r>
-              <a:rPr sz="1300">
-                <a:solidFill>
-                  <a:srgbClr val="3D5466"/>
-                </a:solidFill>
-                <a:latin typeface="Arial"/>
-              </a:rPr>
-              <a:t>▸  ## 4.5 Praxiscase: Ertragsanalyse Bauer &amp; Söhne GmbH</a:t>
-            </a:r>
-          </a:p>
-          <a:p>
-            <a:pPr marL="190500" indent="-190500">
-              <a:spcBef>
-                <a:spcPts val="400"/>
-              </a:spcBef>
-              <a:spcAft>
-                <a:spcPts val="200"/>
-              </a:spcAft>
-            </a:pPr>
-            <a:r>
-              <a:rPr sz="1300">
-                <a:solidFill>
-                  <a:srgbClr val="3D5466"/>
-                </a:solidFill>
-                <a:latin typeface="Arial"/>
-              </a:rPr>
-              <a:t>▸  Ausgangssituation</a:t>
-            </a:r>
-          </a:p>
-          <a:p>
-            <a:pPr marL="190500" indent="-190500">
-              <a:spcBef>
-                <a:spcPts val="400"/>
-              </a:spcBef>
-              <a:spcAft>
-                <a:spcPts val="200"/>
-              </a:spcAft>
-            </a:pPr>
-            <a:r>
-              <a:rPr sz="1300">
-                <a:solidFill>
-                  <a:srgbClr val="3D5466"/>
-                </a:solidFill>
-                <a:latin typeface="Arial"/>
-              </a:rPr>
-              <a:t>▸  Bei der Vorbereitung des Jahresgesprächs analysiert Sandra den Deckungsbeitrag:</a:t>
-            </a:r>
-          </a:p>
-          <a:p>
-            <a:pPr marL="190500" indent="-190500">
-              <a:spcBef>
-                <a:spcPts val="400"/>
-              </a:spcBef>
-              <a:spcAft>
-                <a:spcPts val="200"/>
-              </a:spcAft>
-            </a:pPr>
-            <a:r>
-              <a:rPr sz="1300">
-                <a:solidFill>
-                  <a:srgbClr val="3D5466"/>
-                </a:solidFill>
-                <a:latin typeface="Arial"/>
-              </a:rPr>
-              <a:t>▸  Die Analyse zeigt drei Probleme:</a:t>
-            </a:r>
-          </a:p>
-          <a:p>
-            <a:pPr marL="190500" indent="-190500">
-              <a:spcBef>
-                <a:spcPts val="400"/>
-              </a:spcBef>
-              <a:spcAft>
-                <a:spcPts val="200"/>
-              </a:spcAft>
-            </a:pPr>
-            <a:r>
-              <a:rPr sz="1300">
-                <a:solidFill>
-                  <a:srgbClr val="3D5466"/>
-                </a:solidFill>
-                <a:latin typeface="Arial"/>
-              </a:rPr>
-              <a:t>▸  Die Kreditmarge von 1,25 % deckt den EL von 0,65 % nur mit 0,60 % Nettomarge – unter dem bankinternen Mindeststandard von 0,80 % (fiktiver Fallbeispielwert; die konkrete Untergrenze wird hausindividuell festgelegt).</a:t>
+              <a:t>▸  Ein großer Kredit zu dünner Marge ist ein Verlustgeschäft – wer nur den Zinssatz kennt, verhandelt blind.</a:t>
             </a:r>
           </a:p>
         </p:txBody>
@@ -7365,7 +6810,7 @@
                 </a:solidFill>
                 <a:latin typeface="Arial"/>
               </a:rPr>
-              <a:t>AB-1: Deckungsbeitragsrechnung</a:t>
+              <a:t>Reflexion und Selbstcheck</a:t>
             </a:r>
           </a:p>
         </p:txBody>
@@ -7407,370 +6852,9 @@
                 </a:solidFill>
                 <a:latin typeface="Arial"/>
               </a:rPr>
-              <a:t>▸  Optimierungshebel (Top 2):</a:t>
-            </a:r>
-          </a:p>
-        </p:txBody>
-      </p:sp>
-      <p:sp>
-        <p:nvSpPr>
-          <p:cNvPr id="9" name="Rectangle 8"/>
-          <p:cNvSpPr/>
-          <p:nvPr/>
-        </p:nvSpPr>
-        <p:spPr>
-          <a:xfrm>
-            <a:off x="0" y="6510528"/>
-            <a:ext cx="12188952" cy="347472"/>
-          </a:xfrm>
-          <a:prstGeom prst="rect">
-            <a:avLst/>
-          </a:prstGeom>
-          <a:solidFill>
-            <a:srgbClr val="0A1937"/>
-          </a:solidFill>
-          <a:ln>
-            <a:noFill/>
-          </a:ln>
-        </p:spPr>
-        <p:style>
-          <a:lnRef idx="1">
-            <a:schemeClr val="accent1"/>
-          </a:lnRef>
-          <a:fillRef idx="3">
-            <a:schemeClr val="accent1"/>
-          </a:fillRef>
-          <a:effectRef idx="2">
-            <a:schemeClr val="accent1"/>
-          </a:effectRef>
-          <a:fontRef idx="minor">
-            <a:schemeClr val="lt1"/>
-          </a:fontRef>
-        </p:style>
-        <p:txBody>
-          <a:bodyPr rtlCol="0" anchor="ctr"/>
-          <a:lstStyle/>
-          <a:p>
-            <a:pPr algn="ctr"/>
-          </a:p>
-        </p:txBody>
-      </p:sp>
-      <p:sp>
-        <p:nvSpPr>
-          <p:cNvPr id="10" name="TextBox 9"/>
-          <p:cNvSpPr txBox="1"/>
-          <p:nvPr/>
-        </p:nvSpPr>
-        <p:spPr>
-          <a:xfrm>
-            <a:off x="685800" y="6583680"/>
-            <a:ext cx="6490411" cy="256032"/>
-          </a:xfrm>
-          <a:prstGeom prst="rect">
-            <a:avLst/>
-          </a:prstGeom>
-          <a:noFill/>
-        </p:spPr>
-        <p:txBody>
-          <a:bodyPr wrap="none">
-            <a:spAutoFit/>
-          </a:bodyPr>
-          <a:lstStyle/>
-          <a:p>
-            <a:pPr algn="l"/>
-            <a:r>
-              <a:rPr sz="700">
-                <a:solidFill>
-                  <a:srgbClr val="A0B4D2"/>
-                </a:solidFill>
-                <a:latin typeface="Consolas"/>
-              </a:rPr>
-              <a:t>FKB Campus  ·  M14</a:t>
-            </a:r>
-          </a:p>
-        </p:txBody>
-      </p:sp>
-    </p:spTree>
-  </p:cSld>
-  <p:clrMapOvr>
-    <a:masterClrMapping/>
-  </p:clrMapOvr>
-</p:sld>
-</file>
-
-<file path=ppt/slides/slide16.xml><?xml version="1.0" encoding="utf-8"?>
-<p:sld xmlns:a="http://schemas.openxmlformats.org/drawingml/2006/main" xmlns:p="http://schemas.openxmlformats.org/presentationml/2006/main" xmlns:r="http://schemas.openxmlformats.org/officeDocument/2006/relationships">
-  <p:cSld>
-    <p:spTree>
-      <p:nvGrpSpPr>
-        <p:cNvPr id="1" name=""/>
-        <p:cNvGrpSpPr/>
-        <p:nvPr/>
-      </p:nvGrpSpPr>
-      <p:grpSpPr/>
-      <p:sp>
-        <p:nvSpPr>
-          <p:cNvPr id="2" name="Rectangle 1"/>
-          <p:cNvSpPr/>
-          <p:nvPr/>
-        </p:nvSpPr>
-        <p:spPr>
-          <a:xfrm>
-            <a:off x="0" y="0"/>
-            <a:ext cx="12188952" cy="6858000"/>
-          </a:xfrm>
-          <a:prstGeom prst="rect">
-            <a:avLst/>
-          </a:prstGeom>
-          <a:solidFill>
-            <a:srgbClr val="EDEDF3"/>
-          </a:solidFill>
-          <a:ln>
-            <a:noFill/>
-          </a:ln>
-        </p:spPr>
-        <p:style>
-          <a:lnRef idx="1">
-            <a:schemeClr val="accent1"/>
-          </a:lnRef>
-          <a:fillRef idx="3">
-            <a:schemeClr val="accent1"/>
-          </a:fillRef>
-          <a:effectRef idx="2">
-            <a:schemeClr val="accent1"/>
-          </a:effectRef>
-          <a:fontRef idx="minor">
-            <a:schemeClr val="lt1"/>
-          </a:fontRef>
-        </p:style>
-        <p:txBody>
-          <a:bodyPr rtlCol="0" anchor="ctr"/>
-          <a:lstStyle/>
-          <a:p>
-            <a:pPr algn="ctr"/>
-          </a:p>
-        </p:txBody>
-      </p:sp>
-      <p:sp>
-        <p:nvSpPr>
-          <p:cNvPr id="3" name="Rectangle 2"/>
-          <p:cNvSpPr/>
-          <p:nvPr/>
-        </p:nvSpPr>
-        <p:spPr>
-          <a:xfrm>
-            <a:off x="0" y="0"/>
-            <a:ext cx="12188952" cy="50292"/>
-          </a:xfrm>
-          <a:prstGeom prst="rect">
-            <a:avLst/>
-          </a:prstGeom>
-          <a:solidFill>
-            <a:srgbClr val="1F2C56"/>
-          </a:solidFill>
-          <a:ln>
-            <a:noFill/>
-          </a:ln>
-        </p:spPr>
-        <p:style>
-          <a:lnRef idx="1">
-            <a:schemeClr val="accent1"/>
-          </a:lnRef>
-          <a:fillRef idx="3">
-            <a:schemeClr val="accent1"/>
-          </a:fillRef>
-          <a:effectRef idx="2">
-            <a:schemeClr val="accent1"/>
-          </a:effectRef>
-          <a:fontRef idx="minor">
-            <a:schemeClr val="lt1"/>
-          </a:fontRef>
-        </p:style>
-        <p:txBody>
-          <a:bodyPr rtlCol="0" anchor="ctr"/>
-          <a:lstStyle/>
-          <a:p>
-            <a:pPr algn="ctr"/>
-          </a:p>
-        </p:txBody>
-      </p:sp>
-      <p:sp>
-        <p:nvSpPr>
-          <p:cNvPr id="4" name="TextBox 3"/>
-          <p:cNvSpPr txBox="1"/>
-          <p:nvPr/>
-        </p:nvSpPr>
-        <p:spPr>
-          <a:xfrm>
-            <a:off x="685800" y="109728"/>
-            <a:ext cx="10817352" cy="228600"/>
-          </a:xfrm>
-          <a:prstGeom prst="rect">
-            <a:avLst/>
-          </a:prstGeom>
-          <a:noFill/>
-        </p:spPr>
-        <p:txBody>
-          <a:bodyPr wrap="none">
-            <a:spAutoFit/>
-          </a:bodyPr>
-          <a:lstStyle/>
-          <a:p>
-            <a:pPr algn="l"/>
-            <a:r>
-              <a:rPr sz="750">
-                <a:solidFill>
-                  <a:srgbClr val="78808C"/>
-                </a:solidFill>
-                <a:latin typeface="Consolas"/>
-              </a:rPr>
-              <a:t>M14  ·  INHALT</a:t>
-            </a:r>
-          </a:p>
-        </p:txBody>
-      </p:sp>
-      <p:sp>
-        <p:nvSpPr>
-          <p:cNvPr id="5" name="Rectangle 4"/>
-          <p:cNvSpPr/>
-          <p:nvPr/>
-        </p:nvSpPr>
-        <p:spPr>
-          <a:xfrm>
-            <a:off x="0" y="1234440"/>
-            <a:ext cx="12188952" cy="12700"/>
-          </a:xfrm>
-          <a:prstGeom prst="rect">
-            <a:avLst/>
-          </a:prstGeom>
-          <a:solidFill>
-            <a:srgbClr val="D8DFE4"/>
-          </a:solidFill>
-          <a:ln>
-            <a:noFill/>
-          </a:ln>
-        </p:spPr>
-        <p:style>
-          <a:lnRef idx="1">
-            <a:schemeClr val="accent1"/>
-          </a:lnRef>
-          <a:fillRef idx="3">
-            <a:schemeClr val="accent1"/>
-          </a:fillRef>
-          <a:effectRef idx="2">
-            <a:schemeClr val="accent1"/>
-          </a:effectRef>
-          <a:fontRef idx="minor">
-            <a:schemeClr val="lt1"/>
-          </a:fontRef>
-        </p:style>
-        <p:txBody>
-          <a:bodyPr rtlCol="0" anchor="ctr"/>
-          <a:lstStyle/>
-          <a:p>
-            <a:pPr algn="ctr"/>
-          </a:p>
-        </p:txBody>
-      </p:sp>
-      <p:sp>
-        <p:nvSpPr>
-          <p:cNvPr id="6" name="Rectangle 5"/>
-          <p:cNvSpPr/>
-          <p:nvPr/>
-        </p:nvSpPr>
-        <p:spPr>
-          <a:xfrm>
-            <a:off x="685800" y="502920"/>
-            <a:ext cx="36576" cy="658368"/>
-          </a:xfrm>
-          <a:prstGeom prst="rect">
-            <a:avLst/>
-          </a:prstGeom>
-          <a:solidFill>
-            <a:srgbClr val="D9C089"/>
-          </a:solidFill>
-          <a:ln>
-            <a:noFill/>
-          </a:ln>
-        </p:spPr>
-        <p:style>
-          <a:lnRef idx="1">
-            <a:schemeClr val="accent1"/>
-          </a:lnRef>
-          <a:fillRef idx="3">
-            <a:schemeClr val="accent1"/>
-          </a:fillRef>
-          <a:effectRef idx="2">
-            <a:schemeClr val="accent1"/>
-          </a:effectRef>
-          <a:fontRef idx="minor">
-            <a:schemeClr val="lt1"/>
-          </a:fontRef>
-        </p:style>
-        <p:txBody>
-          <a:bodyPr rtlCol="0" anchor="ctr"/>
-          <a:lstStyle/>
-          <a:p>
-            <a:pPr algn="ctr"/>
-          </a:p>
-        </p:txBody>
-      </p:sp>
-      <p:sp>
-        <p:nvSpPr>
-          <p:cNvPr id="7" name="TextBox 6"/>
-          <p:cNvSpPr txBox="1"/>
-          <p:nvPr/>
-        </p:nvSpPr>
-        <p:spPr>
-          <a:xfrm>
-            <a:off x="813816" y="502920"/>
-            <a:ext cx="10634472" cy="685800"/>
-          </a:xfrm>
-          <a:prstGeom prst="rect">
-            <a:avLst/>
-          </a:prstGeom>
-          <a:noFill/>
-        </p:spPr>
-        <p:txBody>
-          <a:bodyPr wrap="square">
-            <a:spAutoFit/>
-          </a:bodyPr>
-          <a:lstStyle/>
-          <a:p>
-            <a:pPr algn="l"/>
-            <a:r>
-              <a:rPr sz="2400" b="1" i="0">
-                <a:solidFill>
-                  <a:srgbClr val="1F2C56"/>
-                </a:solidFill>
-                <a:latin typeface="Arial"/>
-              </a:rPr>
-              <a:t>AB-2: Konditionengespräch vorbereiten</a:t>
-            </a:r>
-          </a:p>
-        </p:txBody>
-      </p:sp>
-      <p:sp>
-        <p:nvSpPr>
-          <p:cNvPr id="8" name="TextBox 7"/>
-          <p:cNvSpPr txBox="1"/>
-          <p:nvPr/>
-        </p:nvSpPr>
-        <p:spPr>
-          <a:xfrm>
-            <a:off x="685800" y="1417320"/>
-            <a:ext cx="10817352" cy="4892040"/>
-          </a:xfrm>
-          <a:prstGeom prst="rect">
-            <a:avLst/>
-          </a:prstGeom>
-          <a:noFill/>
-        </p:spPr>
-        <p:txBody>
-          <a:bodyPr wrap="square" anchor="ctr">
-            <a:spAutoFit/>
-          </a:bodyPr>
-          <a:lstStyle/>
+              <a:t>▸  Welcher volumenstarke Kunde bringt bei Ihnen womöglich die dünnste Rendite?</a:t>
+            </a:r>
+          </a:p>
           <a:p>
             <a:pPr marL="190500" indent="-190500">
               <a:spcBef>
@@ -7787,7 +6871,7 @@
                 </a:solidFill>
                 <a:latin typeface="Arial"/>
               </a:rPr>
-              <a:t>▸  Wertargumente (Phase 1) – Was hat unsere Beziehung diesem Kunden gebracht?</a:t>
+              <a:t>▸  Welches Signal für Unterpreisierung übersehen Sie im Alltag am ehesten?</a:t>
             </a:r>
           </a:p>
           <a:p>
@@ -7806,45 +6890,7 @@
                 </a:solidFill>
                 <a:latin typeface="Arial"/>
               </a:rPr>
-              <a:t>▸  Marktumfeld-Erklärung (Phase 2) – Welche externen Faktoren begründen die Anpassung?</a:t>
-            </a:r>
-          </a:p>
-          <a:p>
-            <a:pPr marL="190500" indent="-190500">
-              <a:spcBef>
-                <a:spcPts val="400"/>
-              </a:spcBef>
-              <a:spcAft>
-                <a:spcPts val="200"/>
-              </a:spcAft>
-            </a:pPr>
-            <a:r>
-              <a:rPr sz="1300">
-                <a:solidFill>
-                  <a:srgbClr val="3D5466"/>
-                </a:solidFill>
-                <a:latin typeface="Arial"/>
-              </a:rPr>
-              <a:t>▸  Konkrete Anpassung (Phase 3):</a:t>
-            </a:r>
-          </a:p>
-          <a:p>
-            <a:pPr marL="190500" indent="-190500">
-              <a:spcBef>
-                <a:spcPts val="400"/>
-              </a:spcBef>
-              <a:spcAft>
-                <a:spcPts val="200"/>
-              </a:spcAft>
-            </a:pPr>
-            <a:r>
-              <a:rPr sz="1300">
-                <a:solidFill>
-                  <a:srgbClr val="3D5466"/>
-                </a:solidFill>
-                <a:latin typeface="Arial"/>
-              </a:rPr>
-              <a:t>▸  Alternativen (Phase 4) – Welche Optionen biete ich an?</a:t>
+              <a:t>▸  Wie leiten Sie ein Konditionengespräch vom Preis auf den Wert um?</a:t>
             </a:r>
           </a:p>
         </p:txBody>
@@ -9353,7 +8399,7 @@
             <a:avLst/>
           </a:prstGeom>
           <a:solidFill>
-            <a:srgbClr val="FFFFFF"/>
+            <a:srgbClr val="EDEDF3"/>
           </a:solidFill>
           <a:ln>
             <a:noFill/>
@@ -9454,43 +8500,51 @@
                 </a:solidFill>
                 <a:latin typeface="Consolas"/>
               </a:rPr>
-              <a:t>M14  ·  SCHAUBILD</a:t>
-            </a:r>
-          </a:p>
-        </p:txBody>
-      </p:sp>
-      <p:sp>
-        <p:nvSpPr>
-          <p:cNvPr id="5" name="TextBox 4"/>
-          <p:cNvSpPr txBox="1"/>
-          <p:nvPr/>
-        </p:nvSpPr>
-        <p:spPr>
-          <a:xfrm>
-            <a:off x="685800" y="502920"/>
-            <a:ext cx="10817352" cy="594360"/>
-          </a:xfrm>
-          <a:prstGeom prst="rect">
-            <a:avLst/>
-          </a:prstGeom>
-          <a:noFill/>
-        </p:spPr>
-        <p:txBody>
-          <a:bodyPr wrap="square">
-            <a:spAutoFit/>
-          </a:bodyPr>
-          <a:lstStyle/>
-          <a:p>
-            <a:pPr algn="l"/>
-            <a:r>
-              <a:rPr sz="2000" b="1" i="0">
-                <a:solidFill>
-                  <a:srgbClr val="1F2C56"/>
-                </a:solidFill>
-                <a:latin typeface="Arial"/>
-              </a:rPr>
-              <a:t>Deckungsbeitrags-Wasserfall</a:t>
-            </a:r>
+              <a:t>M14  ·  INHALT</a:t>
+            </a:r>
+          </a:p>
+        </p:txBody>
+      </p:sp>
+      <p:sp>
+        <p:nvSpPr>
+          <p:cNvPr id="5" name="Rectangle 4"/>
+          <p:cNvSpPr/>
+          <p:nvPr/>
+        </p:nvSpPr>
+        <p:spPr>
+          <a:xfrm>
+            <a:off x="0" y="1234440"/>
+            <a:ext cx="12188952" cy="12700"/>
+          </a:xfrm>
+          <a:prstGeom prst="rect">
+            <a:avLst/>
+          </a:prstGeom>
+          <a:solidFill>
+            <a:srgbClr val="D8DFE4"/>
+          </a:solidFill>
+          <a:ln>
+            <a:noFill/>
+          </a:ln>
+        </p:spPr>
+        <p:style>
+          <a:lnRef idx="1">
+            <a:schemeClr val="accent1"/>
+          </a:lnRef>
+          <a:fillRef idx="3">
+            <a:schemeClr val="accent1"/>
+          </a:fillRef>
+          <a:effectRef idx="2">
+            <a:schemeClr val="accent1"/>
+          </a:effectRef>
+          <a:fontRef idx="minor">
+            <a:schemeClr val="lt1"/>
+          </a:fontRef>
+        </p:style>
+        <p:txBody>
+          <a:bodyPr rtlCol="0" anchor="ctr"/>
+          <a:lstStyle/>
+          <a:p>
+            <a:pPr algn="ctr"/>
           </a:p>
         </p:txBody>
       </p:sp>
@@ -9502,8 +8556,8 @@
         </p:nvSpPr>
         <p:spPr>
           <a:xfrm>
-            <a:off x="685800" y="1143000"/>
-            <a:ext cx="10817352" cy="25400"/>
+            <a:off x="685800" y="502920"/>
+            <a:ext cx="36576" cy="658368"/>
           </a:xfrm>
           <a:prstGeom prst="rect">
             <a:avLst/>
@@ -9537,33 +8591,124 @@
           </a:p>
         </p:txBody>
       </p:sp>
-      <p:pic>
-        <p:nvPicPr>
-          <p:cNvPr id="7" name="Picture 6" descr="image.png"/>
-          <p:cNvPicPr>
-            <a:picLocks noChangeAspect="1"/>
-          </p:cNvPicPr>
-          <p:nvPr/>
-        </p:nvPicPr>
-        <p:blipFill>
-          <a:blip r:embed="rId2"/>
-          <a:stretch>
-            <a:fillRect/>
-          </a:stretch>
-        </p:blipFill>
-        <p:spPr>
-          <a:xfrm>
-            <a:off x="2303489" y="1325880"/>
-            <a:ext cx="7581973" cy="4937760"/>
-          </a:xfrm>
-          <a:prstGeom prst="rect">
-            <a:avLst/>
-          </a:prstGeom>
-        </p:spPr>
-      </p:pic>
-      <p:sp>
-        <p:nvSpPr>
-          <p:cNvPr id="8" name="Rectangle 7"/>
+      <p:sp>
+        <p:nvSpPr>
+          <p:cNvPr id="7" name="TextBox 6"/>
+          <p:cNvSpPr txBox="1"/>
+          <p:nvPr/>
+        </p:nvSpPr>
+        <p:spPr>
+          <a:xfrm>
+            <a:off x="813816" y="502920"/>
+            <a:ext cx="10634472" cy="685800"/>
+          </a:xfrm>
+          <a:prstGeom prst="rect">
+            <a:avLst/>
+          </a:prstGeom>
+          <a:noFill/>
+        </p:spPr>
+        <p:txBody>
+          <a:bodyPr wrap="square">
+            <a:spAutoFit/>
+          </a:bodyPr>
+          <a:lstStyle/>
+          <a:p>
+            <a:pPr algn="l"/>
+            <a:r>
+              <a:rPr sz="2400" b="1" i="0">
+                <a:solidFill>
+                  <a:srgbClr val="1F2C56"/>
+                </a:solidFill>
+                <a:latin typeface="Arial"/>
+              </a:rPr>
+              <a:t>Nicht das Volumen zählt, sondern der Deckungsbeitrag</a:t>
+            </a:r>
+          </a:p>
+        </p:txBody>
+      </p:sp>
+      <p:sp>
+        <p:nvSpPr>
+          <p:cNvPr id="8" name="TextBox 7"/>
+          <p:cNvSpPr txBox="1"/>
+          <p:nvPr/>
+        </p:nvSpPr>
+        <p:spPr>
+          <a:xfrm>
+            <a:off x="685800" y="1417320"/>
+            <a:ext cx="10817352" cy="4892040"/>
+          </a:xfrm>
+          <a:prstGeom prst="rect">
+            <a:avLst/>
+          </a:prstGeom>
+          <a:noFill/>
+        </p:spPr>
+        <p:txBody>
+          <a:bodyPr wrap="square" anchor="ctr">
+            <a:spAutoFit/>
+          </a:bodyPr>
+          <a:lstStyle/>
+          <a:p>
+            <a:pPr marL="177800" indent="-177800">
+              <a:spcBef>
+                <a:spcPts val="600"/>
+              </a:spcBef>
+              <a:spcAft>
+                <a:spcPts val="200"/>
+              </a:spcAft>
+            </a:pPr>
+            <a:r>
+              <a:rPr sz="1200" i="1">
+                <a:solidFill>
+                  <a:srgbClr val="3D5466"/>
+                </a:solidFill>
+                <a:latin typeface="Arial"/>
+              </a:rPr>
+              <a:t>→  Nicht das Volumen zählt, sondern der Deckungsbeitrag.</a:t>
+            </a:r>
+          </a:p>
+          <a:p>
+            <a:pPr marL="190500" indent="-190500">
+              <a:spcBef>
+                <a:spcPts val="400"/>
+              </a:spcBef>
+              <a:spcAft>
+                <a:spcPts val="200"/>
+              </a:spcAft>
+            </a:pPr>
+            <a:r>
+              <a:rPr sz="1300">
+                <a:solidFill>
+                  <a:srgbClr val="3D5466"/>
+                </a:solidFill>
+                <a:latin typeface="Arial"/>
+              </a:rPr>
+              <a:t>▸  Ein großer Kredit zu dünner Marge ist ein Verlustgeschäft.</a:t>
+            </a:r>
+          </a:p>
+          <a:p>
+            <a:pPr marL="190500" indent="-190500">
+              <a:spcBef>
+                <a:spcPts val="400"/>
+              </a:spcBef>
+              <a:spcAft>
+                <a:spcPts val="200"/>
+              </a:spcAft>
+            </a:pPr>
+            <a:r>
+              <a:rPr sz="1300">
+                <a:solidFill>
+                  <a:srgbClr val="3D5466"/>
+                </a:solidFill>
+                <a:latin typeface="Arial"/>
+              </a:rPr>
+              <a:t>▸  Wer nur den Zinssatz kennt, verhandelt blind – der Deckungsbeitrag zeigt den echten Ertrag je Kunde.</a:t>
+            </a:r>
+          </a:p>
+        </p:txBody>
+      </p:sp>
+      <p:sp>
+        <p:nvSpPr>
+          <p:cNvPr id="9" name="Rectangle 8"/>
           <p:cNvSpPr/>
           <p:nvPr/>
         </p:nvSpPr>
@@ -9606,7 +8751,7 @@
       </p:sp>
       <p:sp>
         <p:nvSpPr>
-          <p:cNvPr id="9" name="TextBox 8"/>
+          <p:cNvPr id="10" name="TextBox 9"/>
           <p:cNvSpPr txBox="1"/>
           <p:nvPr/>
         </p:nvSpPr>
@@ -9635,41 +8780,6 @@
                 <a:latin typeface="Consolas"/>
               </a:rPr>
               <a:t>FKB Campus  ·  M14</a:t>
-            </a:r>
-          </a:p>
-        </p:txBody>
-      </p:sp>
-      <p:sp>
-        <p:nvSpPr>
-          <p:cNvPr id="10" name="TextBox 9"/>
-          <p:cNvSpPr txBox="1"/>
-          <p:nvPr/>
-        </p:nvSpPr>
-        <p:spPr>
-          <a:xfrm>
-            <a:off x="7176211" y="6583680"/>
-            <a:ext cx="4326940" cy="256032"/>
-          </a:xfrm>
-          <a:prstGeom prst="rect">
-            <a:avLst/>
-          </a:prstGeom>
-          <a:noFill/>
-        </p:spPr>
-        <p:txBody>
-          <a:bodyPr wrap="none">
-            <a:spAutoFit/>
-          </a:bodyPr>
-          <a:lstStyle/>
-          <a:p>
-            <a:pPr algn="r"/>
-            <a:r>
-              <a:rPr sz="700">
-                <a:solidFill>
-                  <a:srgbClr val="A0B4D2"/>
-                </a:solidFill>
-                <a:latin typeface="Consolas"/>
-              </a:rPr>
-              <a:t>Schaubild</a:t>
             </a:r>
           </a:p>
         </p:txBody>
@@ -9929,7 +9039,7 @@
                 </a:solidFill>
                 <a:latin typeface="Arial"/>
               </a:rPr>
-              <a:t>Die vier Ertragskomponenten</a:t>
+              <a:t>Die vier Ertragskomponenten je Kunde</a:t>
             </a:r>
           </a:p>
         </p:txBody>
@@ -9955,6 +9065,25 @@
             <a:spAutoFit/>
           </a:bodyPr>
           <a:lstStyle/>
+          <a:p>
+            <a:pPr marL="177800" indent="-177800">
+              <a:spcBef>
+                <a:spcPts val="600"/>
+              </a:spcBef>
+              <a:spcAft>
+                <a:spcPts val="200"/>
+              </a:spcAft>
+            </a:pPr>
+            <a:r>
+              <a:rPr sz="1200" i="1">
+                <a:solidFill>
+                  <a:srgbClr val="3D5466"/>
+                </a:solidFill>
+                <a:latin typeface="Arial"/>
+              </a:rPr>
+              <a:t>→  Der Kundendeckungsbeitrag bündelt alle Ertragsquellen einer Beziehung – nicht nur den Kreditzins.</a:t>
+            </a:r>
+          </a:p>
           <a:p>
             <a:pPr marL="190500" indent="-190500">
               <a:spcBef>
@@ -9971,7 +9100,7 @@
                 </a:solidFill>
                 <a:latin typeface="Arial"/>
               </a:rPr>
-              <a:t>▸  Der Kundendeckungsbeitrag setzt sich zusammen aus:</a:t>
+              <a:t>▸  Zinsergebnis, Provisionen, Verbunderträge, sonstige Erträge.</a:t>
             </a:r>
           </a:p>
           <a:p>
@@ -9990,26 +9119,7 @@
                 </a:solidFill>
                 <a:latin typeface="Arial"/>
               </a:rPr>
-              <a:t>▸  Deckungsbeitrag I = Zinsüberschuss + Provisionsertrag + Verbundertrag − Risikokosten</a:t>
-            </a:r>
-          </a:p>
-          <a:p>
-            <a:pPr marL="190500" indent="-190500">
-              <a:spcBef>
-                <a:spcPts val="400"/>
-              </a:spcBef>
-              <a:spcAft>
-                <a:spcPts val="200"/>
-              </a:spcAft>
-            </a:pPr>
-            <a:r>
-              <a:rPr sz="1300">
-                <a:solidFill>
-                  <a:srgbClr val="3D5466"/>
-                </a:solidFill>
-                <a:latin typeface="Arial"/>
-              </a:rPr>
-              <a:t>▸  Deckungsbeitrag II = DB I − Betriebskosten (Betreuungsaufwand)</a:t>
+              <a:t>▸  Vom Deckungsbeitrag I über die Risikokosten zum Deckungsbeitrag II und zur Kundenrendite.</a:t>
             </a:r>
           </a:p>
         </p:txBody>
@@ -10125,7 +9235,7 @@
             <a:avLst/>
           </a:prstGeom>
           <a:solidFill>
-            <a:srgbClr val="EDEDF3"/>
+            <a:srgbClr val="FFFFFF"/>
           </a:solidFill>
           <a:ln>
             <a:noFill/>
@@ -10226,51 +9336,43 @@
                 </a:solidFill>
                 <a:latin typeface="Consolas"/>
               </a:rPr>
-              <a:t>M14  ·  INHALT</a:t>
-            </a:r>
-          </a:p>
-        </p:txBody>
-      </p:sp>
-      <p:sp>
-        <p:nvSpPr>
-          <p:cNvPr id="5" name="Rectangle 4"/>
-          <p:cNvSpPr/>
-          <p:nvPr/>
-        </p:nvSpPr>
-        <p:spPr>
-          <a:xfrm>
-            <a:off x="0" y="1234440"/>
-            <a:ext cx="12188952" cy="12700"/>
-          </a:xfrm>
-          <a:prstGeom prst="rect">
-            <a:avLst/>
-          </a:prstGeom>
-          <a:solidFill>
-            <a:srgbClr val="D8DFE4"/>
-          </a:solidFill>
-          <a:ln>
-            <a:noFill/>
-          </a:ln>
-        </p:spPr>
-        <p:style>
-          <a:lnRef idx="1">
-            <a:schemeClr val="accent1"/>
-          </a:lnRef>
-          <a:fillRef idx="3">
-            <a:schemeClr val="accent1"/>
-          </a:fillRef>
-          <a:effectRef idx="2">
-            <a:schemeClr val="accent1"/>
-          </a:effectRef>
-          <a:fontRef idx="minor">
-            <a:schemeClr val="lt1"/>
-          </a:fontRef>
-        </p:style>
-        <p:txBody>
-          <a:bodyPr rtlCol="0" anchor="ctr"/>
-          <a:lstStyle/>
-          <a:p>
-            <a:pPr algn="ctr"/>
+              <a:t>M14  ·  SCHAUBILD</a:t>
+            </a:r>
+          </a:p>
+        </p:txBody>
+      </p:sp>
+      <p:sp>
+        <p:nvSpPr>
+          <p:cNvPr id="5" name="TextBox 4"/>
+          <p:cNvSpPr txBox="1"/>
+          <p:nvPr/>
+        </p:nvSpPr>
+        <p:spPr>
+          <a:xfrm>
+            <a:off x="685800" y="502920"/>
+            <a:ext cx="10817352" cy="594360"/>
+          </a:xfrm>
+          <a:prstGeom prst="rect">
+            <a:avLst/>
+          </a:prstGeom>
+          <a:noFill/>
+        </p:spPr>
+        <p:txBody>
+          <a:bodyPr wrap="square">
+            <a:spAutoFit/>
+          </a:bodyPr>
+          <a:lstStyle/>
+          <a:p>
+            <a:pPr algn="l"/>
+            <a:r>
+              <a:rPr sz="2000" b="1" i="0">
+                <a:solidFill>
+                  <a:srgbClr val="1F2C56"/>
+                </a:solidFill>
+                <a:latin typeface="Arial"/>
+              </a:rPr>
+              <a:t>Der Deckungsbeitrags-Wasserfall</a:t>
+            </a:r>
           </a:p>
         </p:txBody>
       </p:sp>
@@ -10282,8 +9384,8 @@
         </p:nvSpPr>
         <p:spPr>
           <a:xfrm>
-            <a:off x="685800" y="502920"/>
-            <a:ext cx="36576" cy="658368"/>
+            <a:off x="685800" y="1143000"/>
+            <a:ext cx="10817352" cy="25400"/>
           </a:xfrm>
           <a:prstGeom prst="rect">
             <a:avLst/>
@@ -10317,105 +9419,33 @@
           </a:p>
         </p:txBody>
       </p:sp>
-      <p:sp>
-        <p:nvSpPr>
-          <p:cNvPr id="7" name="TextBox 6"/>
-          <p:cNvSpPr txBox="1"/>
-          <p:nvPr/>
-        </p:nvSpPr>
-        <p:spPr>
-          <a:xfrm>
-            <a:off x="813816" y="502920"/>
-            <a:ext cx="10634472" cy="685800"/>
-          </a:xfrm>
-          <a:prstGeom prst="rect">
-            <a:avLst/>
-          </a:prstGeom>
-          <a:noFill/>
-        </p:spPr>
-        <p:txBody>
-          <a:bodyPr wrap="square">
-            <a:spAutoFit/>
-          </a:bodyPr>
-          <a:lstStyle/>
-          <a:p>
-            <a:pPr algn="l"/>
-            <a:r>
-              <a:rPr sz="2400" b="1" i="0">
-                <a:solidFill>
-                  <a:srgbClr val="1F2C56"/>
-                </a:solidFill>
-                <a:latin typeface="Arial"/>
-              </a:rPr>
-              <a:t>Rechenbeispiel: Kundendeckungsbeitrag Müller GmbH</a:t>
-            </a:r>
-          </a:p>
-        </p:txBody>
-      </p:sp>
-      <p:sp>
-        <p:nvSpPr>
-          <p:cNvPr id="8" name="TextBox 7"/>
-          <p:cNvSpPr txBox="1"/>
-          <p:nvPr/>
-        </p:nvSpPr>
-        <p:spPr>
-          <a:xfrm>
-            <a:off x="685800" y="1417320"/>
-            <a:ext cx="10817352" cy="4892040"/>
-          </a:xfrm>
-          <a:prstGeom prst="rect">
-            <a:avLst/>
-          </a:prstGeom>
-          <a:noFill/>
-        </p:spPr>
-        <p:txBody>
-          <a:bodyPr wrap="square" anchor="ctr">
-            <a:spAutoFit/>
-          </a:bodyPr>
-          <a:lstStyle/>
-          <a:p>
-            <a:pPr marL="190500" indent="-190500">
-              <a:spcBef>
-                <a:spcPts val="400"/>
-              </a:spcBef>
-              <a:spcAft>
-                <a:spcPts val="200"/>
-              </a:spcAft>
-            </a:pPr>
-            <a:r>
-              <a:rPr sz="1300">
-                <a:solidFill>
-                  <a:srgbClr val="3D5466"/>
-                </a:solidFill>
-                <a:latin typeface="Arial"/>
-              </a:rPr>
-              <a:t>▸  Ertragskennzahl: DB II / Kreditvolumen = 1,58 % (Kundenrendite)</a:t>
-            </a:r>
-          </a:p>
-          <a:p>
-            <a:pPr marL="190500" indent="-190500">
-              <a:spcBef>
-                <a:spcPts val="400"/>
-              </a:spcBef>
-              <a:spcAft>
-                <a:spcPts val="200"/>
-              </a:spcAft>
-            </a:pPr>
-            <a:r>
-              <a:rPr sz="1300">
-                <a:solidFill>
-                  <a:srgbClr val="3D5466"/>
-                </a:solidFill>
-                <a:latin typeface="Arial"/>
-              </a:rPr>
-              <a:t>▸  ## 4.2 Risikogerechtes Pricing</a:t>
-            </a:r>
-          </a:p>
-        </p:txBody>
-      </p:sp>
-      <p:sp>
-        <p:nvSpPr>
-          <p:cNvPr id="9" name="Rectangle 8"/>
+      <p:pic>
+        <p:nvPicPr>
+          <p:cNvPr id="7" name="Picture 6" descr="image.png"/>
+          <p:cNvPicPr>
+            <a:picLocks noChangeAspect="1"/>
+          </p:cNvPicPr>
+          <p:nvPr/>
+        </p:nvPicPr>
+        <p:blipFill>
+          <a:blip r:embed="rId2"/>
+          <a:stretch>
+            <a:fillRect/>
+          </a:stretch>
+        </p:blipFill>
+        <p:spPr>
+          <a:xfrm>
+            <a:off x="2303489" y="1325880"/>
+            <a:ext cx="7581973" cy="4937760"/>
+          </a:xfrm>
+          <a:prstGeom prst="rect">
+            <a:avLst/>
+          </a:prstGeom>
+        </p:spPr>
+      </p:pic>
+      <p:sp>
+        <p:nvSpPr>
+          <p:cNvPr id="8" name="Rectangle 7"/>
           <p:cNvSpPr/>
           <p:nvPr/>
         </p:nvSpPr>
@@ -10458,7 +9488,7 @@
       </p:sp>
       <p:sp>
         <p:nvSpPr>
-          <p:cNvPr id="10" name="TextBox 9"/>
+          <p:cNvPr id="9" name="TextBox 8"/>
           <p:cNvSpPr txBox="1"/>
           <p:nvPr/>
         </p:nvSpPr>
@@ -10487,6 +9517,41 @@
                 <a:latin typeface="Consolas"/>
               </a:rPr>
               <a:t>FKB Campus  ·  M14</a:t>
+            </a:r>
+          </a:p>
+        </p:txBody>
+      </p:sp>
+      <p:sp>
+        <p:nvSpPr>
+          <p:cNvPr id="10" name="TextBox 9"/>
+          <p:cNvSpPr txBox="1"/>
+          <p:nvPr/>
+        </p:nvSpPr>
+        <p:spPr>
+          <a:xfrm>
+            <a:off x="7176211" y="6583680"/>
+            <a:ext cx="4326940" cy="256032"/>
+          </a:xfrm>
+          <a:prstGeom prst="rect">
+            <a:avLst/>
+          </a:prstGeom>
+          <a:noFill/>
+        </p:spPr>
+        <p:txBody>
+          <a:bodyPr wrap="none">
+            <a:spAutoFit/>
+          </a:bodyPr>
+          <a:lstStyle/>
+          <a:p>
+            <a:pPr algn="r"/>
+            <a:r>
+              <a:rPr sz="700">
+                <a:solidFill>
+                  <a:srgbClr val="A0B4D2"/>
+                </a:solidFill>
+                <a:latin typeface="Consolas"/>
+              </a:rPr>
+              <a:t>Schaubild</a:t>
             </a:r>
           </a:p>
         </p:txBody>
@@ -10746,7 +9811,7 @@
                 </a:solidFill>
                 <a:latin typeface="Arial"/>
               </a:rPr>
-              <a:t>Der Expected Loss als Kalkulationsgrundlage</a:t>
+              <a:t>Risikogerechtes Pricing: Expected Loss und NMZ</a:t>
             </a:r>
           </a:p>
         </p:txBody>
@@ -10772,6 +9837,25 @@
             <a:spAutoFit/>
           </a:bodyPr>
           <a:lstStyle/>
+          <a:p>
+            <a:pPr marL="177800" indent="-177800">
+              <a:spcBef>
+                <a:spcPts val="600"/>
+              </a:spcBef>
+              <a:spcAft>
+                <a:spcPts val="200"/>
+              </a:spcAft>
+            </a:pPr>
+            <a:r>
+              <a:rPr sz="1200" i="1">
+                <a:solidFill>
+                  <a:srgbClr val="3D5466"/>
+                </a:solidFill>
+                <a:latin typeface="Arial"/>
+              </a:rPr>
+              <a:t>→  Der Preis muss das Risiko decken – der Expected Loss (PD × LGD × EAD) gehört in jede Kalkulation.</a:t>
+            </a:r>
+          </a:p>
           <a:p>
             <a:pPr marL="190500" indent="-190500">
               <a:spcBef>
@@ -10788,7 +9872,7 @@
                 </a:solidFill>
                 <a:latin typeface="Arial"/>
               </a:rPr>
-              <a:t>▸  In der Konditionenkalkulation muss die Risikoprämie mindestens den Expected Loss (EL) des Kreditengagements abdecken. Der EL errechnet sich nach Basel III  aus:</a:t>
+              <a:t>▸  Expected Loss als Kalkulationsgrundlage; das Nettomargenziel (NMZ) als Steuerungsgröße.</a:t>
             </a:r>
           </a:p>
           <a:p>
@@ -10807,7 +9891,7 @@
                 </a:solidFill>
                 <a:latin typeface="Arial"/>
               </a:rPr>
-              <a:t>▸  EL = PD × LGD × EAD</a:t>
+              <a:t>▸  Konditionsanpassung vorbereiten: wo trägt die Marge das Risiko nicht?</a:t>
             </a:r>
           </a:p>
         </p:txBody>
@@ -10923,7 +10007,7 @@
             <a:avLst/>
           </a:prstGeom>
           <a:solidFill>
-            <a:srgbClr val="EDEDF3"/>
+            <a:srgbClr val="FFFFFF"/>
           </a:solidFill>
           <a:ln>
             <a:noFill/>
@@ -11024,51 +10108,43 @@
                 </a:solidFill>
                 <a:latin typeface="Consolas"/>
               </a:rPr>
-              <a:t>M14  ·  INHALT</a:t>
-            </a:r>
-          </a:p>
-        </p:txBody>
-      </p:sp>
-      <p:sp>
-        <p:nvSpPr>
-          <p:cNvPr id="5" name="Rectangle 4"/>
-          <p:cNvSpPr/>
-          <p:nvPr/>
-        </p:nvSpPr>
-        <p:spPr>
-          <a:xfrm>
-            <a:off x="0" y="1234440"/>
-            <a:ext cx="12188952" cy="12700"/>
-          </a:xfrm>
-          <a:prstGeom prst="rect">
-            <a:avLst/>
-          </a:prstGeom>
-          <a:solidFill>
-            <a:srgbClr val="D8DFE4"/>
-          </a:solidFill>
-          <a:ln>
-            <a:noFill/>
-          </a:ln>
-        </p:spPr>
-        <p:style>
-          <a:lnRef idx="1">
-            <a:schemeClr val="accent1"/>
-          </a:lnRef>
-          <a:fillRef idx="3">
-            <a:schemeClr val="accent1"/>
-          </a:fillRef>
-          <a:effectRef idx="2">
-            <a:schemeClr val="accent1"/>
-          </a:effectRef>
-          <a:fontRef idx="minor">
-            <a:schemeClr val="lt1"/>
-          </a:fontRef>
-        </p:style>
-        <p:txBody>
-          <a:bodyPr rtlCol="0" anchor="ctr"/>
-          <a:lstStyle/>
-          <a:p>
-            <a:pPr algn="ctr"/>
+              <a:t>M14  ·  ÜBERSICHT</a:t>
+            </a:r>
+          </a:p>
+        </p:txBody>
+      </p:sp>
+      <p:sp>
+        <p:nvSpPr>
+          <p:cNvPr id="5" name="TextBox 4"/>
+          <p:cNvSpPr txBox="1"/>
+          <p:nvPr/>
+        </p:nvSpPr>
+        <p:spPr>
+          <a:xfrm>
+            <a:off x="685800" y="502920"/>
+            <a:ext cx="10817352" cy="594360"/>
+          </a:xfrm>
+          <a:prstGeom prst="rect">
+            <a:avLst/>
+          </a:prstGeom>
+          <a:noFill/>
+        </p:spPr>
+        <p:txBody>
+          <a:bodyPr wrap="square">
+            <a:spAutoFit/>
+          </a:bodyPr>
+          <a:lstStyle/>
+          <a:p>
+            <a:pPr algn="l"/>
+            <a:r>
+              <a:rPr sz="2000" b="1" i="0">
+                <a:solidFill>
+                  <a:srgbClr val="1F2C56"/>
+                </a:solidFill>
+                <a:latin typeface="Arial"/>
+              </a:rPr>
+              <a:t>Rechenbeispiel Müller GmbH: Deckungsbeitrag</a:t>
+            </a:r>
           </a:p>
         </p:txBody>
       </p:sp>
@@ -11080,8 +10156,8 @@
         </p:nvSpPr>
         <p:spPr>
           <a:xfrm>
-            <a:off x="685800" y="502920"/>
-            <a:ext cx="36576" cy="658368"/>
+            <a:off x="685800" y="1143000"/>
+            <a:ext cx="10817352" cy="25400"/>
           </a:xfrm>
           <a:prstGeom prst="rect">
             <a:avLst/>
@@ -11115,105 +10191,272 @@
           </a:p>
         </p:txBody>
       </p:sp>
-      <p:sp>
-        <p:nvSpPr>
-          <p:cNvPr id="7" name="TextBox 6"/>
-          <p:cNvSpPr txBox="1"/>
-          <p:nvPr/>
-        </p:nvSpPr>
-        <p:spPr>
-          <a:xfrm>
-            <a:off x="813816" y="502920"/>
-            <a:ext cx="10634472" cy="685800"/>
-          </a:xfrm>
-          <a:prstGeom prst="rect">
-            <a:avLst/>
-          </a:prstGeom>
-          <a:noFill/>
-        </p:spPr>
-        <p:txBody>
-          <a:bodyPr wrap="square">
-            <a:spAutoFit/>
-          </a:bodyPr>
-          <a:lstStyle/>
-          <a:p>
-            <a:pPr algn="l"/>
-            <a:r>
-              <a:rPr sz="2400" b="1" i="0">
-                <a:solidFill>
-                  <a:srgbClr val="1F2C56"/>
-                </a:solidFill>
-                <a:latin typeface="Arial"/>
-              </a:rPr>
-              <a:t>Das Nettomargenziel (NMZ) als Steuerungsgröße</a:t>
-            </a:r>
-          </a:p>
-        </p:txBody>
-      </p:sp>
-      <p:sp>
-        <p:nvSpPr>
-          <p:cNvPr id="8" name="TextBox 7"/>
-          <p:cNvSpPr txBox="1"/>
-          <p:nvPr/>
-        </p:nvSpPr>
-        <p:spPr>
-          <a:xfrm>
-            <a:off x="685800" y="1417320"/>
-            <a:ext cx="10817352" cy="4892040"/>
-          </a:xfrm>
-          <a:prstGeom prst="rect">
-            <a:avLst/>
-          </a:prstGeom>
-          <a:noFill/>
-        </p:spPr>
-        <p:txBody>
-          <a:bodyPr wrap="square" anchor="ctr">
-            <a:spAutoFit/>
-          </a:bodyPr>
-          <a:lstStyle/>
-          <a:p>
-            <a:pPr marL="190500" indent="-190500">
-              <a:spcBef>
-                <a:spcPts val="400"/>
-              </a:spcBef>
-              <a:spcAft>
-                <a:spcPts val="200"/>
-              </a:spcAft>
-            </a:pPr>
-            <a:r>
-              <a:rPr sz="1300">
-                <a:solidFill>
-                  <a:srgbClr val="3D5466"/>
-                </a:solidFill>
-                <a:latin typeface="Arial"/>
-              </a:rPr>
-              <a:t>▸  Logik:</a:t>
-            </a:r>
-          </a:p>
-          <a:p>
-            <a:pPr marL="177800" indent="-177800">
-              <a:spcBef>
-                <a:spcPts val="600"/>
-              </a:spcBef>
-              <a:spcAft>
-                <a:spcPts val="200"/>
-              </a:spcAft>
-            </a:pPr>
-            <a:r>
-              <a:rPr sz="1200" i="1">
-                <a:solidFill>
-                  <a:srgbClr val="3D5466"/>
-                </a:solidFill>
-                <a:latin typeface="Arial"/>
-              </a:rPr>
-              <a:t>→  Bruttomarge (vereinbarte Kreditmarge) − Refinanzierungskosten − EL − Standardbetriebskosten = Nettomarge</a:t>
-            </a:r>
-          </a:p>
-        </p:txBody>
-      </p:sp>
-      <p:sp>
-        <p:nvSpPr>
-          <p:cNvPr id="9" name="Rectangle 8"/>
+      <p:graphicFrame>
+        <p:nvGraphicFramePr>
+          <p:cNvPr id="7" name="Table 6"/>
+          <p:cNvGraphicFramePr>
+            <a:graphicFrameLocks noGrp="1"/>
+          </p:cNvGraphicFramePr>
+          <p:nvPr/>
+        </p:nvGraphicFramePr>
+        <p:xfrm>
+          <a:off x="685800" y="1417320"/>
+          <a:ext cx="10817352" cy="1536192"/>
+        </p:xfrm>
+        <a:graphic>
+          <a:graphicData uri="http://schemas.openxmlformats.org/drawingml/2006/table">
+            <a:tbl>
+              <a:tblPr firstRow="1" bandRow="1">
+                <a:tableStyleId>{5C22544A-7EE6-4342-B048-85BDC9FD1C3A}</a:tableStyleId>
+              </a:tblPr>
+              <a:tblGrid>
+                <a:gridCol w="3605784"/>
+                <a:gridCol w="3605784"/>
+                <a:gridCol w="3605784"/>
+              </a:tblGrid>
+              <a:tr h="384048">
+                <a:tc>
+                  <a:txBody>
+                    <a:bodyPr/>
+                    <a:lstStyle/>
+                    <a:p>
+                      <a:r>
+                        <a:rPr sz="1100" b="1">
+                          <a:solidFill>
+                            <a:srgbClr val="FFFFFF"/>
+                          </a:solidFill>
+                          <a:latin typeface="Arial"/>
+                        </a:rPr>
+                        <a:t>Größe</a:t>
+                      </a:r>
+                    </a:p>
+                  </a:txBody>
+                  <a:tcPr>
+                    <a:solidFill>
+                      <a:srgbClr val="1F2C56"/>
+                    </a:solidFill>
+                  </a:tcPr>
+                </a:tc>
+                <a:tc>
+                  <a:txBody>
+                    <a:bodyPr/>
+                    <a:lstStyle/>
+                    <a:p>
+                      <a:r>
+                        <a:rPr sz="1100" b="1">
+                          <a:solidFill>
+                            <a:srgbClr val="FFFFFF"/>
+                          </a:solidFill>
+                          <a:latin typeface="Arial"/>
+                        </a:rPr>
+                        <a:t>Wert</a:t>
+                      </a:r>
+                    </a:p>
+                  </a:txBody>
+                  <a:tcPr>
+                    <a:solidFill>
+                      <a:srgbClr val="1F2C56"/>
+                    </a:solidFill>
+                  </a:tcPr>
+                </a:tc>
+                <a:tc>
+                  <a:txBody>
+                    <a:bodyPr/>
+                    <a:lstStyle/>
+                    <a:p>
+                      <a:r>
+                        <a:rPr sz="1100" b="1">
+                          <a:solidFill>
+                            <a:srgbClr val="FFFFFF"/>
+                          </a:solidFill>
+                          <a:latin typeface="Arial"/>
+                        </a:rPr>
+                        <a:t>Bewertung</a:t>
+                      </a:r>
+                    </a:p>
+                  </a:txBody>
+                  <a:tcPr>
+                    <a:solidFill>
+                      <a:srgbClr val="1F2C56"/>
+                    </a:solidFill>
+                  </a:tcPr>
+                </a:tc>
+              </a:tr>
+              <a:tr h="384048">
+                <a:tc>
+                  <a:txBody>
+                    <a:bodyPr/>
+                    <a:lstStyle/>
+                    <a:p>
+                      <a:r>
+                        <a:rPr sz="1050">
+                          <a:solidFill>
+                            <a:srgbClr val="3D5466"/>
+                          </a:solidFill>
+                          <a:latin typeface="Arial"/>
+                        </a:rPr>
+                        <a:t>Deckungsbeitrag II</a:t>
+                      </a:r>
+                    </a:p>
+                  </a:txBody>
+                  <a:tcPr/>
+                </a:tc>
+                <a:tc>
+                  <a:txBody>
+                    <a:bodyPr/>
+                    <a:lstStyle/>
+                    <a:p>
+                      <a:r>
+                        <a:rPr sz="1050">
+                          <a:solidFill>
+                            <a:srgbClr val="3D5466"/>
+                          </a:solidFill>
+                          <a:latin typeface="Arial"/>
+                        </a:rPr>
+                        <a:t>12.610 EUR</a:t>
+                      </a:r>
+                    </a:p>
+                  </a:txBody>
+                  <a:tcPr/>
+                </a:tc>
+                <a:tc>
+                  <a:txBody>
+                    <a:bodyPr/>
+                    <a:lstStyle/>
+                    <a:p>
+                      <a:r>
+                        <a:rPr sz="1050">
+                          <a:solidFill>
+                            <a:srgbClr val="3D5466"/>
+                          </a:solidFill>
+                          <a:latin typeface="Arial"/>
+                        </a:rPr>
+                        <a:t>positiv</a:t>
+                      </a:r>
+                    </a:p>
+                  </a:txBody>
+                  <a:tcPr/>
+                </a:tc>
+              </a:tr>
+              <a:tr h="384048">
+                <a:tc>
+                  <a:txBody>
+                    <a:bodyPr/>
+                    <a:lstStyle/>
+                    <a:p>
+                      <a:r>
+                        <a:rPr sz="1050">
+                          <a:solidFill>
+                            <a:srgbClr val="3D5466"/>
+                          </a:solidFill>
+                          <a:latin typeface="Arial"/>
+                        </a:rPr>
+                        <a:t>Kundenrendite</a:t>
+                      </a:r>
+                    </a:p>
+                  </a:txBody>
+                  <a:tcPr/>
+                </a:tc>
+                <a:tc>
+                  <a:txBody>
+                    <a:bodyPr/>
+                    <a:lstStyle/>
+                    <a:p>
+                      <a:r>
+                        <a:rPr sz="1050">
+                          <a:solidFill>
+                            <a:srgbClr val="3D5466"/>
+                          </a:solidFill>
+                          <a:latin typeface="Arial"/>
+                        </a:rPr>
+                        <a:t>1,58 %</a:t>
+                      </a:r>
+                    </a:p>
+                  </a:txBody>
+                  <a:tcPr/>
+                </a:tc>
+                <a:tc>
+                  <a:txBody>
+                    <a:bodyPr/>
+                    <a:lstStyle/>
+                    <a:p>
+                      <a:r>
+                        <a:rPr sz="1050">
+                          <a:solidFill>
+                            <a:srgbClr val="3D5466"/>
+                          </a:solidFill>
+                          <a:latin typeface="Arial"/>
+                        </a:rPr>
+                        <a:t>ausbaufähig</a:t>
+                      </a:r>
+                    </a:p>
+                  </a:txBody>
+                  <a:tcPr/>
+                </a:tc>
+              </a:tr>
+              <a:tr h="384048">
+                <a:tc>
+                  <a:txBody>
+                    <a:bodyPr/>
+                    <a:lstStyle/>
+                    <a:p>
+                      <a:r>
+                        <a:rPr sz="1050">
+                          <a:solidFill>
+                            <a:srgbClr val="3D5466"/>
+                          </a:solidFill>
+                          <a:latin typeface="Arial"/>
+                        </a:rPr>
+                        <a:t>Hebel</a:t>
+                      </a:r>
+                    </a:p>
+                  </a:txBody>
+                  <a:tcPr/>
+                </a:tc>
+                <a:tc>
+                  <a:txBody>
+                    <a:bodyPr/>
+                    <a:lstStyle/>
+                    <a:p>
+                      <a:r>
+                        <a:rPr sz="1050">
+                          <a:solidFill>
+                            <a:srgbClr val="3D5466"/>
+                          </a:solidFill>
+                          <a:latin typeface="Arial"/>
+                        </a:rPr>
+                        <a:t>Cross-Selling / Kondition</a:t>
+                      </a:r>
+                    </a:p>
+                  </a:txBody>
+                  <a:tcPr/>
+                </a:tc>
+                <a:tc>
+                  <a:txBody>
+                    <a:bodyPr/>
+                    <a:lstStyle/>
+                    <a:p>
+                      <a:r>
+                        <a:rPr sz="1050">
+                          <a:solidFill>
+                            <a:srgbClr val="3D5466"/>
+                          </a:solidFill>
+                          <a:latin typeface="Arial"/>
+                        </a:rPr>
+                        <a:t>Wertgespräch</a:t>
+                      </a:r>
+                    </a:p>
+                  </a:txBody>
+                  <a:tcPr/>
+                </a:tc>
+              </a:tr>
+            </a:tbl>
+          </a:graphicData>
+        </a:graphic>
+      </p:graphicFrame>
+      <p:sp>
+        <p:nvSpPr>
+          <p:cNvPr id="8" name="Rectangle 7"/>
           <p:cNvSpPr/>
           <p:nvPr/>
         </p:nvSpPr>
@@ -11256,7 +10499,7 @@
       </p:sp>
       <p:sp>
         <p:nvSpPr>
-          <p:cNvPr id="10" name="TextBox 9"/>
+          <p:cNvPr id="9" name="TextBox 8"/>
           <p:cNvSpPr txBox="1"/>
           <p:nvPr/>
         </p:nvSpPr>
@@ -11285,6 +10528,41 @@
                 <a:latin typeface="Consolas"/>
               </a:rPr>
               <a:t>FKB Campus  ·  M14</a:t>
+            </a:r>
+          </a:p>
+        </p:txBody>
+      </p:sp>
+      <p:sp>
+        <p:nvSpPr>
+          <p:cNvPr id="10" name="TextBox 9"/>
+          <p:cNvSpPr txBox="1"/>
+          <p:nvPr/>
+        </p:nvSpPr>
+        <p:spPr>
+          <a:xfrm>
+            <a:off x="7176211" y="6583680"/>
+            <a:ext cx="4326940" cy="256032"/>
+          </a:xfrm>
+          <a:prstGeom prst="rect">
+            <a:avLst/>
+          </a:prstGeom>
+          <a:noFill/>
+        </p:spPr>
+        <p:txBody>
+          <a:bodyPr wrap="none">
+            <a:spAutoFit/>
+          </a:bodyPr>
+          <a:lstStyle/>
+          <a:p>
+            <a:pPr algn="r"/>
+            <a:r>
+              <a:rPr sz="700">
+                <a:solidFill>
+                  <a:srgbClr val="A0B4D2"/>
+                </a:solidFill>
+                <a:latin typeface="Consolas"/>
+              </a:rPr>
+              <a:t>Übersicht</a:t>
             </a:r>
           </a:p>
         </p:txBody>

</xml_diff>